<commit_message>
Rebuild SAGIP entry on official templates in place with added background studies (2,338 words); move prior versions to old_versions
Co-Authored-By: Claude Sonnet 5.5 <noreply@anthropic.com>
Claude-Session: https://claude.ai/code/session_01BeuSv6ZfopDpEFLv7nhPKY
</commit_message>
<xml_diff>
--- a/sft_entry/SAGIP_SFT2026_Entry_PPT.pptx
+++ b/sft_entry/SAGIP_SFT2026_Entry_PPT.pptx
@@ -9220,7 +9220,7 @@
         </p:nvSpPr>
         <p:spPr>
           <a:xfrm>
-            <a:off x="901950" y="2148840"/>
+            <a:off x="901950" y="2379813"/>
             <a:ext cx="7340100" cy="1516800"/>
           </a:xfrm>
           <a:prstGeom prst="rect">
@@ -9289,14 +9289,6 @@
               </a:rPr>
               <a:t>Aaron Jed E. Campo, Grade 10</a:t>
             </a:r>
-            <a:r>
-              <a:rPr lang="en" sz="1100">
-                <a:solidFill>
-                  <a:schemeClr val="accent3"/>
-                </a:solidFill>
-              </a:rPr>
-              <a:t/>
-            </a:r>
             <a:endParaRPr sz="1100">
               <a:solidFill>
                 <a:schemeClr val="accent3"/>
@@ -9447,23 +9439,7 @@
                   <a:schemeClr val="dk1"/>
                 </a:solidFill>
               </a:rPr>
-              <a:t> </a:t>
-            </a:r>
-            <a:r>
-              <a:rPr i="0" lang="en" sz="1100">
-                <a:solidFill>
-                  <a:schemeClr val="dk1"/>
-                </a:solidFill>
-              </a:rPr>
-              <a:t>Skjoukje U. Jemoya</a:t>
-            </a:r>
-            <a:r>
-              <a:rPr lang="en" sz="1100">
-                <a:solidFill>
-                  <a:schemeClr val="dk1"/>
-                </a:solidFill>
-              </a:rPr>
-              <a:t/>
+              <a:t> Skjoukje U. Jemoya</a:t>
             </a:r>
             <a:endParaRPr sz="1100">
               <a:solidFill>
@@ -9537,8 +9513,8 @@
               <a:buNone/>
             </a:pPr>
             <a:r>
-              <a:rPr b="1" lang="en" sz="1700"/>
-              <a:t>SAGIP: A Low-Cost, Solar-Powered Estero Guardian with On-Chip AI That Lifts Floating Plastic and Counts Every Item as Evidence for Producer Accountability</a:t>
+              <a:rPr b="1" lang="en" sz="2600"/>
+              <a:t>SAGIP: Solar-Powered Estero Guardian with On-Chip AI</a:t>
             </a:r>
             <a:endParaRPr b="1" sz="2600"/>
           </a:p>
@@ -9612,30 +9588,6 @@
               </a:rPr>
               <a:t>Chosen Theme: </a:t>
             </a:r>
-            <a:r>
-              <a:rPr lang="en" sz="1100">
-                <a:solidFill>
-                  <a:schemeClr val="accent3"/>
-                </a:solidFill>
-              </a:rPr>
-              <a:t/>
-            </a:r>
-            <a:r>
-              <a:rPr i="1" lang="en" sz="1100">
-                <a:solidFill>
-                  <a:schemeClr val="accent3"/>
-                </a:solidFill>
-              </a:rPr>
-              <a:t/>
-            </a:r>
-            <a:r>
-              <a:rPr lang="en" sz="1100">
-                <a:solidFill>
-                  <a:schemeClr val="accent3"/>
-                </a:solidFill>
-              </a:rPr>
-              <a:t/>
-            </a:r>
             <a:endParaRPr sz="1100">
               <a:solidFill>
                 <a:schemeClr val="accent3"/>
@@ -9662,7 +9614,30 @@
                   <a:srgbClr val="000000"/>
                 </a:solidFill>
               </a:rPr>
-              <a:t>Environmental Sustainability through Technology</a:t>
+              <a:t>- Environmental Sustainability through Technology</a:t>
+            </a:r>
+            <a:endParaRPr sz="1100">
+              <a:solidFill>
+                <a:srgbClr val="000000"/>
+              </a:solidFill>
+            </a:endParaRPr>
+          </a:p>
+          <a:p>
+            <a:pPr indent="0" lvl="0" marL="0" rtl="0" algn="l">
+              <a:lnSpc>
+                <a:spcPct val="100000"/>
+              </a:lnSpc>
+              <a:spcBef>
+                <a:spcPts val="0"/>
+              </a:spcBef>
+              <a:spcAft>
+                <a:spcPts val="0"/>
+              </a:spcAft>
+              <a:buSzPts val="1800"/>
+              <a:buNone/>
+            </a:pPr>
+            <a:r>
+              <a:t/>
             </a:r>
             <a:endParaRPr sz="1100">
               <a:solidFill>
@@ -9682,8 +9657,8 @@
         </p:nvSpPr>
         <p:spPr>
           <a:xfrm>
-            <a:off x="763800" y="3611880"/>
-            <a:ext cx="7616400" cy="1371600"/>
+            <a:off x="763800" y="3996175"/>
+            <a:ext cx="7616400" cy="769200"/>
           </a:xfrm>
           <a:prstGeom prst="rect">
             <a:avLst/>
@@ -9713,27 +9688,12 @@
               <a:buNone/>
             </a:pPr>
             <a:r>
-              <a:rPr lang="en" sz="1000" i="0">
+              <a:rPr lang="en" sz="1100">
                 <a:solidFill>
                   <a:schemeClr val="dk1"/>
                 </a:solidFill>
               </a:rPr>
-              <a:t>Our device is a low-cost, solar-powered unit in which a floating boom guides surface plastic toward the bank, a camera-triggered sweeper arm lifts it into a bin, and an ESP32-S3 camera running a tiny on-chip AI model counts each item by plastic type. Barangay officials receive a weekly offline report of what was removed and, where labels are legible, who produced it, with no images of people, plus a secondary water-level alert for impending channel blockage. Built from local and upcycled parts for about PHP 6,000 and tested against a hand-counted baseline, it adds anonymized records to an open dataset that other barangays can copy and extend.</a:t>
-            </a:r>
-            <a:br>
-              <a:rPr lang="en" sz="1100">
-                <a:solidFill>
-                  <a:schemeClr val="accent3"/>
-                </a:solidFill>
-              </a:rPr>
-            </a:br>
-            <a:r>
-              <a:rPr i="0" lang="en" sz="1000">
-                <a:solidFill>
-                  <a:schemeClr val="accent3"/>
-                </a:solidFill>
-              </a:rPr>
-              <a:t/>
+              <a:t>Our device is a low-cost, solar-powered unit that lifts floating plastic out of a creek and counts each item with a tiny on-chip AI model. Barangay officials get a weekly offline report of what was removed, plus a secondary water-level alert for blockages. Built for about PHP 6,000 from local parts, it adds anonymized records to an open dataset that other barangays can copy.</a:t>
             </a:r>
             <a:endParaRPr i="1" sz="1100">
               <a:solidFill>
@@ -9790,8 +9750,8 @@
         </p:nvSpPr>
         <p:spPr>
           <a:xfrm>
-            <a:off x="541200" y="1051560"/>
-            <a:ext cx="8061600" cy="3931920"/>
+            <a:off x="541200" y="781650"/>
+            <a:ext cx="8061600" cy="3580200"/>
           </a:xfrm>
           <a:prstGeom prst="rect">
             <a:avLst/>
@@ -9809,10 +9769,10 @@
           <a:p>
             <a:pPr indent="-298450" lvl="0" marL="457200" rtl="0" algn="l">
               <a:lnSpc>
-                <a:spcPct val="105000"/>
-              </a:lnSpc>
-              <a:spcBef>
-                <a:spcPts val="700"/>
+                <a:spcPct val="115000"/>
+              </a:lnSpc>
+              <a:spcBef>
+                <a:spcPts val="1200"/>
               </a:spcBef>
               <a:spcAft>
                 <a:spcPts val="0"/>
@@ -9829,16 +9789,21 @@
                   <a:schemeClr val="dk1"/>
                 </a:solidFill>
               </a:rPr>
-              <a:t>What problem are we trying to solve?</a:t>
+              <a:t>What problem are we trying to solve? </a:t>
             </a:r>
+            <a:endParaRPr b="1" sz="1100">
+              <a:solidFill>
+                <a:schemeClr val="dk1"/>
+              </a:solidFill>
+            </a:endParaRPr>
           </a:p>
           <a:p>
             <a:pPr indent="0" lvl="0" marL="0" rtl="0" algn="l">
               <a:lnSpc>
-                <a:spcPct val="105000"/>
-              </a:lnSpc>
-              <a:spcBef>
-                <a:spcPts val="400"/>
+                <a:spcPct val="115000"/>
+              </a:lnSpc>
+              <a:spcBef>
+                <a:spcPts val="1200"/>
               </a:spcBef>
               <a:spcAft>
                 <a:spcPts val="0"/>
@@ -9852,32 +9817,21 @@
                   <a:schemeClr val="dk1"/>
                 </a:solidFill>
               </a:rPr>
-              <a:t>Plastic reaches the sea through creeks and esteros, and Philippine rivers rank among the largest sources of ocean plastic (Meijer et al., 2021). Cleanups weigh trash in bulk and record nothing about it. RA 11898 makes producers responsible for packaging, but brand audits are periodic, manual and mostly land-based (Break Free From Plastic, 2019). </a:t>
+              <a:t>Philippine rivers rank among the largest sources of ocean plastic (Jambeck et al., 2015, Lebreton et al., 2017, Meijer et al., 2021), and small urban esteros feed them. Cleanups weigh bulk waste and record nothing about it. Brand audits are periodic and mostly land-based (Break Free From Plastic, 2019), and RA 11898 needs proof of which packaging reaches waterways. The gap is a continuous, low-cost record taken at the creek itself.</a:t>
             </a:r>
-            <a:r>
-              <a:rPr lang="en" sz="1100" b="1">
-                <a:solidFill>
-                  <a:schemeClr val="dk1"/>
-                </a:solidFill>
-              </a:rPr>
-              <a:t>The gap:</a:t>
-            </a:r>
-            <a:r>
-              <a:rPr lang="en" sz="1100">
-                <a:solidFill>
-                  <a:schemeClr val="dk1"/>
-                </a:solidFill>
-              </a:rPr>
-              <a:t> a continuous, low-cost record taken at the creek itself that one barangay can run. A blocked channel is a related hazard.</a:t>
-            </a:r>
+            <a:endParaRPr sz="1100">
+              <a:solidFill>
+                <a:schemeClr val="dk1"/>
+              </a:solidFill>
+            </a:endParaRPr>
           </a:p>
           <a:p>
             <a:pPr indent="-298450" lvl="0" marL="457200" rtl="0" algn="l">
               <a:lnSpc>
-                <a:spcPct val="105000"/>
-              </a:lnSpc>
-              <a:spcBef>
-                <a:spcPts val="700"/>
+                <a:spcPct val="115000"/>
+              </a:lnSpc>
+              <a:spcBef>
+                <a:spcPts val="1200"/>
               </a:spcBef>
               <a:spcAft>
                 <a:spcPts val="0"/>
@@ -9896,14 +9850,19 @@
               </a:rPr>
               <a:t>What do we want to achieve?</a:t>
             </a:r>
+            <a:endParaRPr b="1" sz="1100">
+              <a:solidFill>
+                <a:schemeClr val="dk1"/>
+              </a:solidFill>
+            </a:endParaRPr>
           </a:p>
           <a:p>
             <a:pPr indent="0" lvl="0" marL="0" rtl="0" algn="l">
               <a:lnSpc>
-                <a:spcPct val="105000"/>
-              </a:lnSpc>
-              <a:spcBef>
-                <a:spcPts val="400"/>
+                <a:spcPct val="115000"/>
+              </a:lnSpc>
+              <a:spcBef>
+                <a:spcPts val="1200"/>
               </a:spcBef>
               <a:spcAft>
                 <a:spcPts val="0"/>
@@ -9912,7 +9871,7 @@
               <a:buNone/>
             </a:pPr>
             <a:r>
-              <a:rPr lang="en" sz="1100" b="1">
+              <a:rPr b="1" lang="en" sz="1100">
                 <a:solidFill>
                   <a:schemeClr val="dk1"/>
                 </a:solidFill>
@@ -9925,16 +9884,21 @@
                   <a:schemeClr val="dk1"/>
                 </a:solidFill>
               </a:rPr>
-              <a:t>make creek plastic measurable evidence instead of invisible waste, with cleaner creeks now and community-owned data that shifts the burden of proof to packaging producers.</a:t>
+              <a:t>make creek plastic measurable evidence instead of invisible waste, with cleaner creeks and community-owned data.</a:t>
             </a:r>
+            <a:endParaRPr sz="1100">
+              <a:solidFill>
+                <a:schemeClr val="dk1"/>
+              </a:solidFill>
+            </a:endParaRPr>
           </a:p>
           <a:p>
             <a:pPr indent="0" lvl="0" marL="0" rtl="0" algn="l">
               <a:lnSpc>
-                <a:spcPct val="105000"/>
-              </a:lnSpc>
-              <a:spcBef>
-                <a:spcPts val="400"/>
+                <a:spcPct val="115000"/>
+              </a:lnSpc>
+              <a:spcBef>
+                <a:spcPts val="1200"/>
               </a:spcBef>
               <a:spcAft>
                 <a:spcPts val="0"/>
@@ -9943,20 +9907,12 @@
               <a:buNone/>
             </a:pPr>
             <a:r>
-              <a:rPr lang="en" sz="1100" b="1">
+              <a:rPr b="1" lang="en" sz="1100">
                 <a:solidFill>
                   <a:schemeClr val="dk1"/>
                 </a:solidFill>
               </a:rPr>
-              <a:t>Objectives (SMART): </a:t>
-            </a:r>
-            <a:r>
-              <a:rPr lang="en" sz="1100" b="1">
-                <a:solidFill>
-                  <a:schemeClr val="dk1"/>
-                </a:solidFill>
-              </a:rPr>
-              <a:t>1. Remove plastic.</a:t>
+              <a:t>Objectives</a:t>
             </a:r>
             <a:r>
               <a:rPr lang="en" sz="1100">
@@ -9964,48 +9920,21 @@
                   <a:schemeClr val="dk1"/>
                 </a:solidFill>
               </a:rPr>
-              <a:t> In an 8-week pilot from December 2026, lift at least [TARGET] kg of floating debris and capture at least [X]% of what reaches the boom, against a baseline week. </a:t>
+              <a:t>: (1) In an 8-week pilot from December 2026, lift at least [TARGET] kg of floating debris and capture at least [X]% of what reaches the boom. (2) By November 20, reach 85% precision and recall on unseen photos, with weekly counts within 15% of a hand audit. (3) By March 2027, publish an open dataset and build guide and help [2] more barangays or schools build a PHP 6,000 unit.</a:t>
             </a:r>
-            <a:r>
-              <a:rPr lang="en" sz="1100" b="1">
-                <a:solidFill>
-                  <a:schemeClr val="dk1"/>
-                </a:solidFill>
-              </a:rPr>
-              <a:t>2. Prove what it is.</a:t>
-            </a:r>
-            <a:r>
-              <a:rPr lang="en" sz="1100">
-                <a:solidFill>
-                  <a:schemeClr val="dk1"/>
-                </a:solidFill>
-              </a:rPr>
-              <a:t> By Nov 20, reach 85% precision and recall on unseen photos, then keep weekly counts within 15% of a hand audit. </a:t>
-            </a:r>
-            <a:r>
-              <a:rPr lang="en" sz="1100" b="1">
-                <a:solidFill>
-                  <a:schemeClr val="dk1"/>
-                </a:solidFill>
-              </a:rPr>
-              <a:t>3. Make it copyable.</a:t>
-            </a:r>
-            <a:r>
-              <a:rPr lang="en" sz="1100">
-                <a:solidFill>
-                  <a:schemeClr val="dk1"/>
-                </a:solidFill>
-              </a:rPr>
-              <a:t> By March 2027, a free build guide in English and Filipino, an open dataset, and 2+ more barangays or schools building a unit for about PHP 6,000.</a:t>
-            </a:r>
+            <a:endParaRPr sz="1100">
+              <a:solidFill>
+                <a:schemeClr val="dk1"/>
+              </a:solidFill>
+            </a:endParaRPr>
           </a:p>
           <a:p>
             <a:pPr indent="-298450" lvl="0" marL="457200" rtl="0" algn="l">
               <a:lnSpc>
-                <a:spcPct val="105000"/>
-              </a:lnSpc>
-              <a:spcBef>
-                <a:spcPts val="700"/>
+                <a:spcPct val="115000"/>
+              </a:lnSpc>
+              <a:spcBef>
+                <a:spcPts val="1200"/>
               </a:spcBef>
               <a:spcAft>
                 <a:spcPts val="0"/>
@@ -10014,7 +9943,7 @@
                 <a:schemeClr val="dk1"/>
               </a:buClr>
               <a:buSzPts val="1100"/>
-              <a:buAutoNum type="arabicPeriod"/>
+              <a:buAutoNum type="arabicPeriod" startAt="3"/>
             </a:pPr>
             <a:r>
               <a:rPr b="1" lang="en" sz="1100">
@@ -10024,23 +9953,32 @@
               </a:rPr>
               <a:t>Who will benefit from this project?</a:t>
             </a:r>
+            <a:endParaRPr b="1" sz="1100">
+              <a:solidFill>
+                <a:schemeClr val="dk1"/>
+              </a:solidFill>
+            </a:endParaRPr>
           </a:p>
           <a:p>
             <a:pPr indent="0" lvl="0" marL="0" rtl="0" algn="l">
               <a:lnSpc>
-                <a:spcPct val="105000"/>
-              </a:lnSpc>
-              <a:spcBef>
-                <a:spcPts val="400"/>
-              </a:spcBef>
-              <a:spcAft>
-                <a:spcPts val="0"/>
-              </a:spcAft>
+                <a:spcPct val="115000"/>
+              </a:lnSpc>
+              <a:spcBef>
+                <a:spcPts val="1200"/>
+              </a:spcBef>
+              <a:spcAft>
+                <a:spcPts val="1200"/>
+              </a:spcAft>
+              <a:buClr>
+                <a:schemeClr val="dk1"/>
+              </a:buClr>
               <a:buSzPts val="1800"/>
+              <a:buFont typeface="Arial"/>
               <a:buNone/>
             </a:pPr>
             <a:r>
-              <a:rPr lang="en" sz="1100" b="1">
+              <a:rPr b="1" lang="en" sz="1100">
                 <a:solidFill>
                   <a:schemeClr val="dk1"/>
                 </a:solidFill>
@@ -10056,7 +9994,7 @@
               <a:t>the [N] households of [barangay and purok] along [estero] and the barangay sanitation officers. </a:t>
             </a:r>
             <a:r>
-              <a:rPr lang="en" sz="1100" b="1">
+              <a:rPr b="1" lang="en" sz="1100">
                 <a:solidFill>
                   <a:schemeClr val="dk1"/>
                 </a:solidFill>
@@ -10069,8 +10007,13 @@
                   <a:schemeClr val="dk1"/>
                 </a:solidFill>
               </a:rPr>
-              <a:t>the city solid-waste office and DENR, who need item-level evidence, 2+ more barangays or schools by March 2027, and downstream fisherfolk.</a:t>
+              <a:t>the city solid-waste office and DENR, [2] more barangays or schools, and downstream fisherfolk.</a:t>
             </a:r>
+            <a:endParaRPr sz="1100">
+              <a:solidFill>
+                <a:schemeClr val="dk1"/>
+              </a:solidFill>
+            </a:endParaRPr>
           </a:p>
         </p:txBody>
       </p:sp>
@@ -10121,8 +10064,8 @@
         </p:nvSpPr>
         <p:spPr>
           <a:xfrm>
-            <a:off x="541200" y="1051560"/>
-            <a:ext cx="8061600" cy="3931920"/>
+            <a:off x="541200" y="1902750"/>
+            <a:ext cx="8061600" cy="1338000"/>
           </a:xfrm>
           <a:prstGeom prst="rect">
             <a:avLst/>
@@ -10140,10 +10083,10 @@
           <a:p>
             <a:pPr indent="-298450" lvl="0" marL="457200" rtl="0" algn="l">
               <a:lnSpc>
-                <a:spcPct val="105000"/>
-              </a:lnSpc>
-              <a:spcBef>
-                <a:spcPts val="700"/>
+                <a:spcPct val="115000"/>
+              </a:lnSpc>
+              <a:spcBef>
+                <a:spcPts val="1200"/>
               </a:spcBef>
               <a:spcAft>
                 <a:spcPts val="0"/>
@@ -10162,23 +10105,32 @@
               </a:rPr>
               <a:t>How did we come up with this proposal?</a:t>
             </a:r>
+            <a:endParaRPr b="1" sz="1100">
+              <a:solidFill>
+                <a:schemeClr val="dk1"/>
+              </a:solidFill>
+            </a:endParaRPr>
           </a:p>
           <a:p>
             <a:pPr indent="0" lvl="0" marL="0" rtl="0" algn="l">
               <a:lnSpc>
-                <a:spcPct val="105000"/>
-              </a:lnSpc>
-              <a:spcBef>
-                <a:spcPts val="400"/>
-              </a:spcBef>
-              <a:spcAft>
-                <a:spcPts val="0"/>
-              </a:spcAft>
+                <a:spcPct val="115000"/>
+              </a:lnSpc>
+              <a:spcBef>
+                <a:spcPts val="1200"/>
+              </a:spcBef>
+              <a:spcAft>
+                <a:spcPts val="0"/>
+              </a:spcAft>
+              <a:buClr>
+                <a:schemeClr val="dk1"/>
+              </a:buClr>
               <a:buSzPts val="1800"/>
+              <a:buFont typeface="Arial"/>
               <a:buNone/>
             </a:pPr>
             <a:r>
-              <a:rPr lang="en" sz="1100" b="1">
+              <a:rPr b="1" lang="en" sz="1100">
                 <a:solidFill>
                   <a:schemeClr val="dk1"/>
                 </a:solidFill>
@@ -10191,25 +10143,34 @@
                   <a:schemeClr val="dk1"/>
                 </a:solidFill>
               </a:rPr>
-              <a:t>We scored five community problems on significance, feasibility, STEM depth, replicability and originality. Creek plastic won. We can reach a creek, measure it weekly, and RA 11898 has just made item-level data useful. [Edit to match your process.]</a:t>
+              <a:t>We scored five community problems on significance, feasibility, STEM depth, replicability and originality. Creek plastic won. [Edit to match your process.]</a:t>
             </a:r>
+            <a:endParaRPr b="1" sz="1100">
+              <a:solidFill>
+                <a:schemeClr val="dk1"/>
+              </a:solidFill>
+            </a:endParaRPr>
           </a:p>
           <a:p>
             <a:pPr indent="0" lvl="0" marL="0" rtl="0" algn="l">
               <a:lnSpc>
-                <a:spcPct val="105000"/>
-              </a:lnSpc>
-              <a:spcBef>
-                <a:spcPts val="400"/>
-              </a:spcBef>
-              <a:spcAft>
-                <a:spcPts val="0"/>
-              </a:spcAft>
+                <a:spcPct val="115000"/>
+              </a:lnSpc>
+              <a:spcBef>
+                <a:spcPts val="1200"/>
+              </a:spcBef>
+              <a:spcAft>
+                <a:spcPts val="0"/>
+              </a:spcAft>
+              <a:buClr>
+                <a:schemeClr val="dk1"/>
+              </a:buClr>
               <a:buSzPts val="1800"/>
+              <a:buFont typeface="Arial"/>
               <a:buNone/>
             </a:pPr>
             <a:r>
-              <a:rPr lang="en" sz="1100" b="1">
+              <a:rPr b="1" lang="en" sz="1100">
                 <a:solidFill>
                   <a:schemeClr val="dk1"/>
                 </a:solidFill>
@@ -10222,25 +10183,34 @@
                   <a:schemeClr val="dk1"/>
                 </a:solidFill>
               </a:rPr>
-              <a:t>Cameras with deep learning count floating plastic from bridges but remove nothing (van Lieshout et al., 2020). Low-cost robotic boats detect and collect plastic but need radio, charging and an operator (HydroSentinel, 2026). Estero trash traps remove plastic at scale but record bulk weight only (Manila Bulletin, 2026). Brand audits name the companies but are periodic and manual (Break Free From Plastic, 2019).</a:t>
+              <a:t>Cameras count floating plastic but remove nothing (van Lieshout et al., 2020). Robotic boats collect it but need radio and an operator (HydroSentinel, 2026). Trash traps and interceptors remove it in bulk with little item-level data (Manila Bulletin, 2026, Schmaltz et al., 2020). Brand audits name companies but are manual (Break Free From Plastic, 2019).</a:t>
             </a:r>
+            <a:endParaRPr b="1" sz="1100">
+              <a:solidFill>
+                <a:schemeClr val="dk1"/>
+              </a:solidFill>
+            </a:endParaRPr>
           </a:p>
           <a:p>
             <a:pPr indent="0" lvl="0" marL="0" rtl="0" algn="l">
               <a:lnSpc>
-                <a:spcPct val="105000"/>
-              </a:lnSpc>
-              <a:spcBef>
-                <a:spcPts val="400"/>
-              </a:spcBef>
-              <a:spcAft>
-                <a:spcPts val="0"/>
-              </a:spcAft>
+                <a:spcPct val="115000"/>
+              </a:lnSpc>
+              <a:spcBef>
+                <a:spcPts val="1200"/>
+              </a:spcBef>
+              <a:spcAft>
+                <a:spcPts val="0"/>
+              </a:spcAft>
+              <a:buClr>
+                <a:schemeClr val="dk1"/>
+              </a:buClr>
               <a:buSzPts val="1800"/>
+              <a:buFont typeface="Arial"/>
               <a:buNone/>
             </a:pPr>
             <a:r>
-              <a:rPr lang="en" sz="1100" b="1">
+              <a:rPr b="1" lang="en" sz="1100">
                 <a:solidFill>
                   <a:schemeClr val="dk1"/>
                 </a:solidFill>
@@ -10253,25 +10223,34 @@
                   <a:schemeClr val="dk1"/>
                 </a:solidFill>
               </a:rPr>
-              <a:t>None of these lifts, counts and shares open data in a unit a barangay can afford. Our search was limited. We ask: can a PHP 6,000 on-chip counter match a trained hand audit within 15%, and does continuous counting reveal rain-driven pulses of plastic that weekly audits miss?</a:t>
+              <a:t>No system we found lifts, counts and shares open data at barangay cost. Can a PHP 6,000 on-chip counter match a hand audit within 15%, and does continuous counting show rain-driven pulses of plastic (Cordova &amp; Nurhati, 2019) that weekly audits miss?</a:t>
             </a:r>
+            <a:endParaRPr b="1" sz="1100">
+              <a:solidFill>
+                <a:schemeClr val="dk1"/>
+              </a:solidFill>
+            </a:endParaRPr>
           </a:p>
           <a:p>
             <a:pPr indent="0" lvl="0" marL="0" rtl="0" algn="l">
               <a:lnSpc>
-                <a:spcPct val="105000"/>
-              </a:lnSpc>
-              <a:spcBef>
-                <a:spcPts val="400"/>
-              </a:spcBef>
-              <a:spcAft>
-                <a:spcPts val="0"/>
-              </a:spcAft>
+                <a:spcPct val="115000"/>
+              </a:lnSpc>
+              <a:spcBef>
+                <a:spcPts val="1200"/>
+              </a:spcBef>
+              <a:spcAft>
+                <a:spcPts val="1200"/>
+              </a:spcAft>
+              <a:buClr>
+                <a:schemeClr val="dk1"/>
+              </a:buClr>
               <a:buSzPts val="1800"/>
+              <a:buFont typeface="Arial"/>
               <a:buNone/>
             </a:pPr>
             <a:r>
-              <a:rPr lang="en" sz="1100" b="1">
+              <a:rPr b="1" lang="en" sz="1100">
                 <a:solidFill>
                   <a:schemeClr val="dk1"/>
                 </a:solidFill>
@@ -10284,8 +10263,13 @@
                   <a:schemeClr val="dk1"/>
                 </a:solidFill>
               </a:rPr>
-              <a:t>Break Free From Plastic 2019; HydroSentinel 2026 (ScienceDirect); Manila Bulletin 2026; Meijer 2021 (Science Advances); RA 11898; van Lieshout 2020 (Earth and Space Science).</a:t>
+              <a:t>Break Free From Plastic and GAIA 2019, Cordova &amp; Nurhati 2019, David et al. 2021, HydroSentinel 2026, Jacob et al. 2018, Jambeck et al. 2015, Lebreton et al. 2017, Manila Bulletin 2026, Meijer et al. 2021, RA 11898, Schmaltz et al. 2020, van Lieshout et al. 2020.</a:t>
             </a:r>
+            <a:endParaRPr b="1" sz="1100">
+              <a:solidFill>
+                <a:schemeClr val="dk1"/>
+              </a:solidFill>
+            </a:endParaRPr>
           </a:p>
         </p:txBody>
       </p:sp>
@@ -10336,8 +10320,8 @@
         </p:nvSpPr>
         <p:spPr>
           <a:xfrm>
-            <a:off x="539496" y="1051560"/>
-            <a:ext cx="4526280" cy="3931920"/>
+            <a:off x="541200" y="1928100"/>
+            <a:ext cx="8061600" cy="1287300"/>
           </a:xfrm>
           <a:prstGeom prst="rect">
             <a:avLst/>
@@ -10355,10 +10339,10 @@
           <a:p>
             <a:pPr indent="-298450" lvl="0" marL="457200" rtl="0" algn="l">
               <a:lnSpc>
-                <a:spcPct val="105000"/>
-              </a:lnSpc>
-              <a:spcBef>
-                <a:spcPts val="700"/>
+                <a:spcPct val="115000"/>
+              </a:lnSpc>
+              <a:spcBef>
+                <a:spcPts val="1200"/>
               </a:spcBef>
               <a:spcAft>
                 <a:spcPts val="0"/>
@@ -10377,14 +10361,19 @@
               </a:rPr>
               <a:t>How will this tech solution work?</a:t>
             </a:r>
+            <a:endParaRPr b="1" sz="1100">
+              <a:solidFill>
+                <a:schemeClr val="dk1"/>
+              </a:solidFill>
+            </a:endParaRPr>
           </a:p>
           <a:p>
             <a:pPr indent="0" lvl="0" marL="0" rtl="0" algn="l">
               <a:lnSpc>
-                <a:spcPct val="105000"/>
-              </a:lnSpc>
-              <a:spcBef>
-                <a:spcPts val="400"/>
+                <a:spcPct val="115000"/>
+              </a:lnSpc>
+              <a:spcBef>
+                <a:spcPts val="1200"/>
               </a:spcBef>
               <a:spcAft>
                 <a:spcPts val="0"/>
@@ -10393,12 +10382,12 @@
               <a:buNone/>
             </a:pPr>
             <a:r>
-              <a:rPr lang="en" sz="1100" b="1">
+              <a:rPr b="1" lang="en" sz="1100">
                 <a:solidFill>
                   <a:schemeClr val="dk1"/>
                 </a:solidFill>
               </a:rPr>
-              <a:t>Trap: </a:t>
+              <a:t>Summary. </a:t>
             </a:r>
             <a:r>
               <a:rPr lang="en" sz="1100">
@@ -10406,16 +10395,21 @@
                   <a:schemeClr val="dk1"/>
                 </a:solidFill>
               </a:rPr>
-              <a:t>a boom of reused bottles guides plastic to a bar screen. The current does the herding, and a wide-gapped deflector lets hyacinth mats pass.</a:t>
+              <a:t>A floating boom guides plastic to a bar screen, a camera-triggered arm lifts it into a bin, and an ESP32-S3 camera counts each item on the chip with an INT8 model (Jacob et al., 2018, David et al., 2021). An offline Wi-Fi page gives the barangay a weekly report and an open dataset. An ultrasonic sensor warns of rising water as a secondary function. A shear pin, current and Hall sensing and a three-retry lockout protect against jams.</a:t>
             </a:r>
+            <a:endParaRPr b="1" sz="1100">
+              <a:solidFill>
+                <a:schemeClr val="dk1"/>
+              </a:solidFill>
+            </a:endParaRPr>
           </a:p>
           <a:p>
             <a:pPr indent="0" lvl="0" marL="0" rtl="0" algn="l">
               <a:lnSpc>
-                <a:spcPct val="105000"/>
-              </a:lnSpc>
-              <a:spcBef>
-                <a:spcPts val="400"/>
+                <a:spcPct val="115000"/>
+              </a:lnSpc>
+              <a:spcBef>
+                <a:spcPts val="1200"/>
               </a:spcBef>
               <a:spcAft>
                 <a:spcPts val="0"/>
@@ -10424,12 +10418,12 @@
               <a:buNone/>
             </a:pPr>
             <a:r>
-              <a:rPr lang="en" sz="1100" b="1">
+              <a:rPr b="1" lang="en" sz="1100">
                 <a:solidFill>
                   <a:schemeClr val="dk1"/>
                 </a:solidFill>
               </a:rPr>
-              <a:t>Lift: </a:t>
+              <a:t>STEM. </a:t>
             </a:r>
             <a:r>
               <a:rPr lang="en" sz="1100">
@@ -10437,30 +10431,35 @@
                   <a:schemeClr val="dk1"/>
                 </a:solidFill>
               </a:rPr>
-              <a:t>a camera-triggered arm sweeps debris up a ramp into a bin. A shear pin protects the gearbox, and current and Hall sensors stop jams, with at most three retries.</a:t>
+              <a:t>Physics sets buoyancy, torque and the solar budget. Mathematics defines precision, recall and count error. Computer science supplies the quantized model. Engineering joins them in a weatherproof floating structure.</a:t>
             </a:r>
+            <a:endParaRPr b="1" sz="1100">
+              <a:solidFill>
+                <a:schemeClr val="dk1"/>
+              </a:solidFill>
+            </a:endParaRPr>
           </a:p>
           <a:p>
             <a:pPr indent="0" lvl="0" marL="0" rtl="0" algn="l">
               <a:lnSpc>
-                <a:spcPct val="105000"/>
-              </a:lnSpc>
-              <a:spcBef>
-                <a:spcPts val="400"/>
-              </a:spcBef>
-              <a:spcAft>
-                <a:spcPts val="0"/>
+                <a:spcPct val="115000"/>
+              </a:lnSpc>
+              <a:spcBef>
+                <a:spcPts val="1200"/>
+              </a:spcBef>
+              <a:spcAft>
+                <a:spcPts val="1200"/>
               </a:spcAft>
               <a:buSzPts val="1800"/>
               <a:buNone/>
             </a:pPr>
             <a:r>
-              <a:rPr lang="en" sz="1100" b="1">
+              <a:rPr b="1" lang="en" sz="1100">
                 <a:solidFill>
                   <a:schemeClr val="dk1"/>
                 </a:solidFill>
               </a:rPr>
-              <a:t>Count: </a:t>
+              <a:t>Key message. </a:t>
             </a:r>
             <a:r>
               <a:rPr lang="en" sz="1100">
@@ -10468,180 +10467,13 @@
                   <a:schemeClr val="dk1"/>
                 </a:solidFill>
               </a:rPr>
-              <a:t>an ESP32-S3 camera looks down at the water only, and an INT8 model classifies each item on the chip. Weekly hand counts check it.</a:t>
+              <a:t>Proof of what plastic reaches a creek can be continuous, cheap and community-owned, and one chip delivers cleanup and evidence together.</a:t>
             </a:r>
-          </a:p>
-          <a:p>
-            <a:pPr indent="0" lvl="0" marL="0" rtl="0" algn="l">
-              <a:lnSpc>
-                <a:spcPct val="105000"/>
-              </a:lnSpc>
-              <a:spcBef>
-                <a:spcPts val="400"/>
-              </a:spcBef>
-              <a:spcAft>
-                <a:spcPts val="0"/>
-              </a:spcAft>
-              <a:buSzPts val="1800"/>
-              <a:buNone/>
-            </a:pPr>
-            <a:r>
-              <a:rPr lang="en" sz="1100" b="1">
-                <a:solidFill>
-                  <a:schemeClr val="dk1"/>
-                </a:solidFill>
-              </a:rPr>
-              <a:t>Report: </a:t>
-            </a:r>
-            <a:r>
-              <a:rPr lang="en" sz="1100">
-                <a:solidFill>
-                  <a:schemeClr val="dk1"/>
-                </a:solidFill>
-              </a:rPr>
-              <a:t>an offline Wi-Fi page gives the barangay a weekly report and an open dataset. </a:t>
-            </a:r>
-            <a:r>
-              <a:rPr lang="en" sz="1100" b="1">
-                <a:solidFill>
-                  <a:schemeClr val="dk1"/>
-                </a:solidFill>
-              </a:rPr>
-              <a:t>Warn (secondary): </a:t>
-            </a:r>
-            <a:r>
-              <a:rPr lang="en" sz="1100">
-                <a:solidFill>
-                  <a:schemeClr val="dk1"/>
-                </a:solidFill>
-              </a:rPr>
-              <a:t>an ultrasonic sensor logs the water level and alerts before a blockage.</a:t>
-            </a:r>
-          </a:p>
-          <a:p>
-            <a:pPr indent="0" lvl="0" marL="0" rtl="0" algn="l">
-              <a:lnSpc>
-                <a:spcPct val="105000"/>
-              </a:lnSpc>
-              <a:spcBef>
-                <a:spcPts val="400"/>
-              </a:spcBef>
-              <a:spcAft>
-                <a:spcPts val="0"/>
-              </a:spcAft>
-              <a:buSzPts val="1800"/>
-              <a:buNone/>
-            </a:pPr>
-            <a:r>
-              <a:rPr lang="en" sz="1100" b="1">
-                <a:solidFill>
-                  <a:schemeClr val="dk1"/>
-                </a:solidFill>
-              </a:rPr>
-              <a:t>STEM: </a:t>
-            </a:r>
-            <a:r>
-              <a:rPr lang="en" sz="1100">
-                <a:solidFill>
-                  <a:schemeClr val="dk1"/>
-                </a:solidFill>
-              </a:rPr>
-              <a:t>buoyancy and torque, a solar energy budget, precision and recall, and a quantized AI model. Pairing a collector with a counter delivers cleanup and evidence from one cheap chip.</a:t>
-            </a:r>
-          </a:p>
-        </p:txBody>
-      </p:sp>
-      <p:pic>
-        <p:nvPicPr>
-          <p:cNvPr id="73" name="Picture 72" descr="fig_dev.png"/>
-          <p:cNvPicPr>
-            <a:picLocks noChangeAspect="1"/>
-          </p:cNvPicPr>
-          <p:nvPr/>
-        </p:nvPicPr>
-        <p:blipFill>
-          <a:blip r:embed="rId4"/>
-          <a:stretch>
-            <a:fillRect/>
-          </a:stretch>
-        </p:blipFill>
-        <p:spPr>
-          <a:xfrm>
-            <a:off x="5166360" y="914400"/>
-            <a:ext cx="3520440" cy="1992569"/>
-          </a:xfrm>
-          <a:prstGeom prst="rect">
-            <a:avLst/>
-          </a:prstGeom>
-        </p:spPr>
-      </p:pic>
-      <p:sp>
-        <p:nvSpPr>
-          <p:cNvPr id="74" name="TextBox 73"/>
-          <p:cNvSpPr txBox="1"/>
-          <p:nvPr/>
-        </p:nvSpPr>
-        <p:spPr>
-          <a:xfrm>
-            <a:off x="5120640" y="3108960"/>
-            <a:ext cx="3611880" cy="1737360"/>
-          </a:xfrm>
-          <a:prstGeom prst="rect">
-            <a:avLst/>
-          </a:prstGeom>
-          <a:noFill/>
-        </p:spPr>
-        <p:txBody>
-          <a:bodyPr wrap="square">
-            <a:spAutoFit/>
-          </a:bodyPr>
-          <a:lstStyle/>
-          <a:p>
-            <a:pPr indent="0" lvl="0" marL="0" rtl="0" algn="l">
-              <a:lnSpc>
-                <a:spcPct val="105000"/>
-              </a:lnSpc>
-              <a:spcBef>
-                <a:spcPts val="0"/>
-              </a:spcBef>
-              <a:spcAft>
-                <a:spcPts val="0"/>
-              </a:spcAft>
-              <a:buSzPts val="1800"/>
-              <a:buNone/>
-            </a:pPr>
-            <a:r>
-              <a:rPr lang="en" sz="1100" b="1">
-                <a:solidFill>
-                  <a:schemeClr val="dk1"/>
-                </a:solidFill>
-              </a:rPr>
-              <a:t>In plain words: </a:t>
-            </a:r>
-            <a:r>
-              <a:rPr lang="en" sz="1100">
-                <a:solidFill>
-                  <a:schemeClr val="dk1"/>
-                </a:solidFill>
-              </a:rPr>
-              <a:t>the model is the skill of a sanitation worker who can tell a PET bottle from a sachet at a glance, saved as a file of numbers. </a:t>
-            </a:r>
-            <a:r>
-              <a:rPr lang="en" sz="1100" b="1">
-                <a:solidFill>
-                  <a:schemeClr val="dk1"/>
-                </a:solidFill>
-              </a:rPr>
-              <a:t>Quantization</a:t>
-            </a:r>
-            <a:r>
-              <a:rPr lang="en" sz="1100">
-                <a:solidFill>
-                  <a:schemeClr val="dk1"/>
-                </a:solidFill>
-              </a:rPr>
-              <a:t> rounds the numbers like a gradebook (87, not 87.3416), so the file fits the chip. No internet is needed.</a:t>
-            </a:r>
+            <a:endParaRPr b="1" sz="1100">
+              <a:solidFill>
+                <a:schemeClr val="dk1"/>
+              </a:solidFill>
+            </a:endParaRPr>
           </a:p>
         </p:txBody>
       </p:sp>
@@ -10692,8 +10524,8 @@
         </p:nvSpPr>
         <p:spPr>
           <a:xfrm>
-            <a:off x="541200" y="1051560"/>
-            <a:ext cx="8061600" cy="3931920"/>
+            <a:off x="541200" y="1284450"/>
+            <a:ext cx="8061600" cy="2574600"/>
           </a:xfrm>
           <a:prstGeom prst="rect">
             <a:avLst/>
@@ -10711,10 +10543,10 @@
           <a:p>
             <a:pPr indent="-298450" lvl="0" marL="457200" rtl="0" algn="l">
               <a:lnSpc>
-                <a:spcPct val="105000"/>
-              </a:lnSpc>
-              <a:spcBef>
-                <a:spcPts val="700"/>
+                <a:spcPct val="115000"/>
+              </a:lnSpc>
+              <a:spcBef>
+                <a:spcPts val="1200"/>
               </a:spcBef>
               <a:spcAft>
                 <a:spcPts val="0"/>
@@ -10733,14 +10565,19 @@
               </a:rPr>
               <a:t>How do we implement this?</a:t>
             </a:r>
+            <a:endParaRPr b="1" sz="1100">
+              <a:solidFill>
+                <a:schemeClr val="dk1"/>
+              </a:solidFill>
+            </a:endParaRPr>
           </a:p>
           <a:p>
             <a:pPr indent="0" lvl="0" marL="0" rtl="0" algn="l">
               <a:lnSpc>
-                <a:spcPct val="105000"/>
-              </a:lnSpc>
-              <a:spcBef>
-                <a:spcPts val="400"/>
+                <a:spcPct val="115000"/>
+              </a:lnSpc>
+              <a:spcBef>
+                <a:spcPts val="1200"/>
               </a:spcBef>
               <a:spcAft>
                 <a:spcPts val="0"/>
@@ -10749,20 +10586,40 @@
               <a:buNone/>
             </a:pPr>
             <a:r>
-              <a:rPr lang="en" sz="1100" b="1">
+              <a:rPr lang="en" sz="1100">
                 <a:solidFill>
                   <a:schemeClr val="dk1"/>
                 </a:solidFill>
               </a:rPr>
-              <a:t>Resources: </a:t>
+              <a:t>A pilot unit costs about PHP 6,000, built in three stages that are each bought only after the previous test passes.</a:t>
             </a:r>
+            <a:endParaRPr sz="1100">
+              <a:solidFill>
+                <a:schemeClr val="dk1"/>
+              </a:solidFill>
+            </a:endParaRPr>
+          </a:p>
+          <a:p>
+            <a:pPr indent="0" lvl="0" marL="0" rtl="0" algn="l">
+              <a:lnSpc>
+                <a:spcPct val="115000"/>
+              </a:lnSpc>
+              <a:spcBef>
+                <a:spcPts val="1200"/>
+              </a:spcBef>
+              <a:spcAft>
+                <a:spcPts val="0"/>
+              </a:spcAft>
+              <a:buSzPts val="1800"/>
+              <a:buNone/>
+            </a:pPr>
             <a:r>
-              <a:rPr lang="en" sz="1100" b="1">
+              <a:rPr b="1" lang="en" sz="1100">
                 <a:solidFill>
                   <a:schemeClr val="dk1"/>
                 </a:solidFill>
               </a:rPr>
-              <a:t>pilot unit about PHP 6,000</a:t>
+              <a:t>Resources:</a:t>
             </a:r>
             <a:r>
               <a:rPr lang="en" sz="1100">
@@ -10770,16 +10627,21 @@
                   <a:schemeClr val="dk1"/>
                 </a:solidFill>
               </a:rPr>
-              <a:t> (ESP32-S3 camera 1,300, microSD 200, box 300, solar panel 600, charger and cells 700, boom and post 800, bin 150, wiring 250, level sensor 350, motor and driver 700, sensing 150, ramp and arm 150, contingency 350), estimates to confirm. Built in stages: bench 1,800, passive trap 2,500, arm and sensor 1,350, each bought after a test passes. Timeline: site visit and baseline by Nov 2, model by Nov 20, results Dec 7, pilot Dec to Feb, build guide by March.</a:t>
+              <a:t> ESP32-S3 camera board 1,300, microSD 200, box 300, solar panel 600, charger and cells 700, boom and post 800, bin and gauge 150, wiring 250, level sensor 350, motor and driver 700, sensing 150, ramp and arm 150, contingency 350. Stages: bench 1,800, passive trap 2,500, arm and sensor 1,350. Timeline: model by Nov 20, results Dec 7, pilot Dec to Feb, guide by March.</a:t>
             </a:r>
+            <a:endParaRPr sz="1100">
+              <a:solidFill>
+                <a:schemeClr val="dk1"/>
+              </a:solidFill>
+            </a:endParaRPr>
           </a:p>
           <a:p>
             <a:pPr indent="0" lvl="0" marL="0" rtl="0" algn="l">
               <a:lnSpc>
-                <a:spcPct val="105000"/>
-              </a:lnSpc>
-              <a:spcBef>
-                <a:spcPts val="400"/>
+                <a:spcPct val="115000"/>
+              </a:lnSpc>
+              <a:spcBef>
+                <a:spcPts val="1200"/>
               </a:spcBef>
               <a:spcAft>
                 <a:spcPts val="0"/>
@@ -10788,20 +10650,12 @@
               <a:buNone/>
             </a:pPr>
             <a:r>
-              <a:rPr lang="en" sz="1100" b="1">
+              <a:rPr b="1" lang="en" sz="1100">
                 <a:solidFill>
                   <a:schemeClr val="dk1"/>
                 </a:solidFill>
               </a:rPr>
-              <a:t>Stakeholders: </a:t>
-            </a:r>
-            <a:r>
-              <a:rPr lang="en" sz="1100" b="1">
-                <a:solidFill>
-                  <a:schemeClr val="dk1"/>
-                </a:solidFill>
-              </a:rPr>
-              <a:t>barangay captain and sanitation officers</a:t>
+              <a:t>Stakeholders:</a:t>
             </a:r>
             <a:r>
               <a:rPr lang="en" sz="1100">
@@ -10809,15 +10663,35 @@
                   <a:schemeClr val="dk1"/>
                 </a:solidFill>
               </a:rPr>
-              <a:t> (site approval, weekly emptying, use of reports under a one-page maintenance agreement), </a:t>
+              <a:t> barangay captain and sanitation officers (site approval, weekly emptying, one-page agreement), city solid-waste office and DENR (use the data), adviser and school head (supervision, safety), and residents (consent).</a:t>
             </a:r>
+            <a:endParaRPr sz="1100">
+              <a:solidFill>
+                <a:schemeClr val="dk1"/>
+              </a:solidFill>
+            </a:endParaRPr>
+          </a:p>
+          <a:p>
+            <a:pPr indent="0" lvl="0" marL="0" rtl="0" algn="l">
+              <a:lnSpc>
+                <a:spcPct val="115000"/>
+              </a:lnSpc>
+              <a:spcBef>
+                <a:spcPts val="1200"/>
+              </a:spcBef>
+              <a:spcAft>
+                <a:spcPts val="1200"/>
+              </a:spcAft>
+              <a:buSzPts val="1800"/>
+              <a:buNone/>
+            </a:pPr>
             <a:r>
-              <a:rPr lang="en" sz="1100" b="1">
+              <a:rPr b="1" lang="en" sz="1100">
                 <a:solidFill>
                   <a:schemeClr val="dk1"/>
                 </a:solidFill>
               </a:rPr>
-              <a:t>city solid-waste office and DENR</a:t>
+              <a:t>Risks &amp; Mitigation:</a:t>
             </a:r>
             <a:r>
               <a:rPr lang="en" sz="1100">
@@ -10825,191 +10699,13 @@
                   <a:schemeClr val="dk1"/>
                 </a:solidFill>
               </a:rPr>
-              <a:t> (use the data), </a:t>
+              <a:t> Hyacinth mats: deflector and a vegetation class that stops the arm. Jams: shear pin, current and Hall sensing, three retries. Oil and silt: motor mounted high, sealed bearings. Model errors: test on unseen places and keep the hand count. Arm failure: boom, bin and camera still work. Safety and privacy: no one enters the water and the camera sees water only.</a:t>
             </a:r>
-            <a:r>
-              <a:rPr lang="en" sz="1100" b="1">
-                <a:solidFill>
-                  <a:schemeClr val="dk1"/>
-                </a:solidFill>
-              </a:rPr>
-              <a:t>adviser and school head</a:t>
-            </a:r>
-            <a:r>
-              <a:rPr lang="en" sz="1100">
-                <a:solidFill>
-                  <a:schemeClr val="dk1"/>
-                </a:solidFill>
-              </a:rPr>
-              <a:t> (supervision, safety sign-off), </a:t>
-            </a:r>
-            <a:r>
-              <a:rPr lang="en" sz="1100" b="1">
-                <a:solidFill>
-                  <a:schemeClr val="dk1"/>
-                </a:solidFill>
-              </a:rPr>
-              <a:t>students</a:t>
-            </a:r>
-            <a:r>
-              <a:rPr lang="en" sz="1100">
-                <a:solidFill>
-                  <a:schemeClr val="dk1"/>
-                </a:solidFill>
-              </a:rPr>
-              <a:t> (build, label, count, report) and </a:t>
-            </a:r>
-            <a:r>
-              <a:rPr lang="en" sz="1100" b="1">
-                <a:solidFill>
-                  <a:schemeClr val="dk1"/>
-                </a:solidFill>
-              </a:rPr>
-              <a:t>residents</a:t>
-            </a:r>
-            <a:r>
-              <a:rPr lang="en" sz="1100">
-                <a:solidFill>
-                  <a:schemeClr val="dk1"/>
-                </a:solidFill>
-              </a:rPr>
-              <a:t> (consent, a clear site).</a:t>
-            </a:r>
-          </a:p>
-          <a:p>
-            <a:pPr indent="0" lvl="0" marL="0" rtl="0" algn="l">
-              <a:lnSpc>
-                <a:spcPct val="105000"/>
-              </a:lnSpc>
-              <a:spcBef>
-                <a:spcPts val="400"/>
-              </a:spcBef>
-              <a:spcAft>
-                <a:spcPts val="0"/>
-              </a:spcAft>
-              <a:buSzPts val="1800"/>
-              <a:buNone/>
-            </a:pPr>
-            <a:r>
-              <a:rPr lang="en" sz="1100" b="1">
-                <a:solidFill>
-                  <a:schemeClr val="dk1"/>
-                </a:solidFill>
-              </a:rPr>
-              <a:t>Risks &amp; Mitigation: </a:t>
-            </a:r>
-            <a:r>
-              <a:rPr lang="en" sz="1100" b="1">
-                <a:solidFill>
-                  <a:schemeClr val="dk1"/>
-                </a:solidFill>
-              </a:rPr>
-              <a:t>Hyacinth mats</a:t>
-            </a:r>
-            <a:r>
-              <a:rPr lang="en" sz="1100">
-                <a:solidFill>
-                  <a:schemeClr val="dk1"/>
-                </a:solidFill>
-              </a:rPr>
-              <a:t>: deflector, a vegetation class that stops the arm, daily screen clearing. </a:t>
-            </a:r>
-            <a:r>
-              <a:rPr lang="en" sz="1100" b="1">
-                <a:solidFill>
-                  <a:schemeClr val="dk1"/>
-                </a:solidFill>
-              </a:rPr>
-              <a:t>Jams and burnout</a:t>
-            </a:r>
-            <a:r>
-              <a:rPr lang="en" sz="1100">
-                <a:solidFill>
-                  <a:schemeClr val="dk1"/>
-                </a:solidFill>
-              </a:rPr>
-              <a:t>: shear pin, current and Hall sensing, three retries, driver off by default. </a:t>
-            </a:r>
-            <a:r>
-              <a:rPr lang="en" sz="1100" b="1">
-                <a:solidFill>
-                  <a:schemeClr val="dk1"/>
-                </a:solidFill>
-              </a:rPr>
-              <a:t>Oil and silt</a:t>
-            </a:r>
-            <a:r>
-              <a:rPr lang="en" sz="1100">
-                <a:solidFill>
-                  <a:schemeClr val="dk1"/>
-                </a:solidFill>
-              </a:rPr>
-              <a:t>: motor mounted high, sealed bearings, hooded lens. </a:t>
-            </a:r>
-            <a:r>
-              <a:rPr lang="en" sz="1100" b="1">
-                <a:solidFill>
-                  <a:schemeClr val="dk1"/>
-                </a:solidFill>
-              </a:rPr>
-              <a:t>Model errors</a:t>
-            </a:r>
-            <a:r>
-              <a:rPr lang="en" sz="1100">
-                <a:solidFill>
-                  <a:schemeClr val="dk1"/>
-                </a:solidFill>
-              </a:rPr>
-              <a:t>: test on unseen places, keep the hand count. </a:t>
-            </a:r>
-            <a:r>
-              <a:rPr lang="en" sz="1100" b="1">
-                <a:solidFill>
-                  <a:schemeClr val="dk1"/>
-                </a:solidFill>
-              </a:rPr>
-              <a:t>Arm fails</a:t>
-            </a:r>
-            <a:r>
-              <a:rPr lang="en" sz="1100">
-                <a:solidFill>
-                  <a:schemeClr val="dk1"/>
-                </a:solidFill>
-              </a:rPr>
-              <a:t>: boom, bin and camera still work, so the data pilot survives. </a:t>
-            </a:r>
-            <a:r>
-              <a:rPr lang="en" sz="1100" b="1">
-                <a:solidFill>
-                  <a:schemeClr val="dk1"/>
-                </a:solidFill>
-              </a:rPr>
-              <a:t>Safety and privacy</a:t>
-            </a:r>
-            <a:r>
-              <a:rPr lang="en" sz="1100">
-                <a:solidFill>
-                  <a:schemeClr val="dk1"/>
-                </a:solidFill>
-              </a:rPr>
-              <a:t>: no student enters the water, guarded arm, camera sees water only. </a:t>
-            </a:r>
-            <a:r>
-              <a:rPr lang="en" sz="1100" b="1">
-                <a:solidFill>
-                  <a:schemeClr val="dk1"/>
-                </a:solidFill>
-              </a:rPr>
-              <a:t>Storms and theft</a:t>
-            </a:r>
-            <a:r>
-              <a:rPr lang="en" sz="1100">
-                <a:solidFill>
-                  <a:schemeClr val="dk1"/>
-                </a:solidFill>
-              </a:rPr>
-              <a:t>: quick-release line, electronics retrieved before a typhoon.</a:t>
-            </a:r>
+            <a:endParaRPr sz="1100">
+              <a:solidFill>
+                <a:schemeClr val="dk1"/>
+              </a:solidFill>
+            </a:endParaRPr>
           </a:p>
         </p:txBody>
       </p:sp>
@@ -11060,8 +10756,8 @@
         </p:nvSpPr>
         <p:spPr>
           <a:xfrm>
-            <a:off x="541200" y="1051560"/>
-            <a:ext cx="8061600" cy="3931920"/>
+            <a:off x="541200" y="1284450"/>
+            <a:ext cx="8061600" cy="3359100"/>
           </a:xfrm>
           <a:prstGeom prst="rect">
             <a:avLst/>
@@ -11079,10 +10775,10 @@
           <a:p>
             <a:pPr indent="-298450" lvl="0" marL="457200" rtl="0" algn="l">
               <a:lnSpc>
-                <a:spcPct val="105000"/>
-              </a:lnSpc>
-              <a:spcBef>
-                <a:spcPts val="700"/>
+                <a:spcPct val="115000"/>
+              </a:lnSpc>
+              <a:spcBef>
+                <a:spcPts val="1200"/>
               </a:spcBef>
               <a:spcAft>
                 <a:spcPts val="0"/>
@@ -11101,14 +10797,19 @@
               </a:rPr>
               <a:t>What kind of impact do we hope to achieve and what is the long term vision for this proposal?</a:t>
             </a:r>
+            <a:endParaRPr b="1" sz="1100">
+              <a:solidFill>
+                <a:schemeClr val="dk1"/>
+              </a:solidFill>
+            </a:endParaRPr>
           </a:p>
           <a:p>
             <a:pPr indent="0" lvl="0" marL="0" rtl="0" algn="l">
               <a:lnSpc>
-                <a:spcPct val="105000"/>
-              </a:lnSpc>
-              <a:spcBef>
-                <a:spcPts val="400"/>
+                <a:spcPct val="115000"/>
+              </a:lnSpc>
+              <a:spcBef>
+                <a:spcPts val="1200"/>
               </a:spcBef>
               <a:spcAft>
                 <a:spcPts val="0"/>
@@ -11122,16 +10823,21 @@
                   <a:schemeClr val="dk1"/>
                 </a:solidFill>
               </a:rPr>
-              <a:t>Success means plastic lifted from a real creek and a trustworthy weekly record of what it was. One unit lifts little, so the value lies in a design cheap enough to copy and data open enough to combine.</a:t>
+              <a:t>Success means plastic lifted from a real creek and a trustworthy weekly record of what it was.</a:t>
             </a:r>
+            <a:endParaRPr sz="1100">
+              <a:solidFill>
+                <a:schemeClr val="dk1"/>
+              </a:solidFill>
+            </a:endParaRPr>
           </a:p>
           <a:p>
             <a:pPr indent="0" lvl="0" marL="0" rtl="0" algn="l">
               <a:lnSpc>
-                <a:spcPct val="105000"/>
-              </a:lnSpc>
-              <a:spcBef>
-                <a:spcPts val="400"/>
+                <a:spcPct val="115000"/>
+              </a:lnSpc>
+              <a:spcBef>
+                <a:spcPts val="1200"/>
               </a:spcBef>
               <a:spcAft>
                 <a:spcPts val="0"/>
@@ -11140,12 +10846,12 @@
               <a:buNone/>
             </a:pPr>
             <a:r>
-              <a:rPr lang="en" sz="1100" b="1">
+              <a:rPr b="1" lang="en" sz="1100">
                 <a:solidFill>
                   <a:schemeClr val="dk1"/>
                 </a:solidFill>
               </a:rPr>
-              <a:t>Measurable Outcomes: 1. Less plastic: </a:t>
+              <a:t>Measurable Outcomes:</a:t>
             </a:r>
             <a:r>
               <a:rPr lang="en" sz="1100">
@@ -11153,15 +10859,35 @@
                   <a:schemeClr val="dk1"/>
                 </a:solidFill>
               </a:rPr>
-              <a:t>at least [TARGET] kg lifted in 8 weeks, capture rate of at least [X]% against the baseline. </a:t>
+              <a:t> (1) At least [TARGET] kg lifted in 8 weeks, with a capture rate of at least [X]% against a baseline week. (2) Weekly counts within 15% of the hand audit, and 85% precision and recall on unseen places. (3) At least [2] more sites by March 2027 at about PHP 6,000 each, sharing one open data format.</a:t>
             </a:r>
+            <a:endParaRPr sz="1100">
+              <a:solidFill>
+                <a:schemeClr val="dk1"/>
+              </a:solidFill>
+            </a:endParaRPr>
+          </a:p>
+          <a:p>
+            <a:pPr indent="0" lvl="0" marL="0" rtl="0" algn="l">
+              <a:lnSpc>
+                <a:spcPct val="115000"/>
+              </a:lnSpc>
+              <a:spcBef>
+                <a:spcPts val="1200"/>
+              </a:spcBef>
+              <a:spcAft>
+                <a:spcPts val="0"/>
+              </a:spcAft>
+              <a:buSzPts val="1800"/>
+              <a:buNone/>
+            </a:pPr>
             <a:r>
-              <a:rPr lang="en" sz="1100" b="1">
+              <a:rPr b="1" lang="en" sz="1100">
                 <a:solidFill>
                   <a:schemeClr val="dk1"/>
                 </a:solidFill>
               </a:rPr>
-              <a:t>2. Trustworthy counts: </a:t>
+              <a:t>Long-Term Vision:</a:t>
             </a:r>
             <a:r>
               <a:rPr lang="en" sz="1100">
@@ -11169,15 +10895,35 @@
                   <a:schemeClr val="dk1"/>
                 </a:solidFill>
               </a:rPr>
-              <a:t>weekly error of 15% or less against the hand audit, and 85% precision and recall on unseen places. </a:t>
+              <a:t> a student-built, barangay-owned network of units along connected creeks, feeding one open dataset that shows where plastic enters, which products dominate and whether EPR commitments change what the water carries. Planned upgrades are a belt conveyor and a second camera angle.</a:t>
             </a:r>
+            <a:endParaRPr sz="1100">
+              <a:solidFill>
+                <a:schemeClr val="dk1"/>
+              </a:solidFill>
+            </a:endParaRPr>
+          </a:p>
+          <a:p>
+            <a:pPr indent="0" lvl="0" marL="0" rtl="0" algn="l">
+              <a:lnSpc>
+                <a:spcPct val="115000"/>
+              </a:lnSpc>
+              <a:spcBef>
+                <a:spcPts val="1200"/>
+              </a:spcBef>
+              <a:spcAft>
+                <a:spcPts val="1200"/>
+              </a:spcAft>
+              <a:buSzPts val="1800"/>
+              <a:buNone/>
+            </a:pPr>
             <a:r>
-              <a:rPr lang="en" sz="1100" b="1">
+              <a:rPr b="1" lang="en" sz="1100">
                 <a:solidFill>
                   <a:schemeClr val="dk1"/>
                 </a:solidFill>
               </a:rPr>
-              <a:t>3. Replication: </a:t>
+              <a:t>Key Takeaway:</a:t>
             </a:r>
             <a:r>
               <a:rPr lang="en" sz="1100">
@@ -11185,70 +10931,13 @@
                   <a:schemeClr val="dk1"/>
                 </a:solidFill>
               </a:rPr>
-              <a:t>2+ more sites by March 2027 at about PHP 6,000 each, sharing one open data format.</a:t>
+              <a:t> the Philippines already knows who makes much of its plastic. SAGIP makes the proof continuous, cheap and community-owned, and lifts some of the plastic out along the way.</a:t>
             </a:r>
-          </a:p>
-          <a:p>
-            <a:pPr indent="0" lvl="0" marL="0" rtl="0" algn="l">
-              <a:lnSpc>
-                <a:spcPct val="105000"/>
-              </a:lnSpc>
-              <a:spcBef>
-                <a:spcPts val="400"/>
-              </a:spcBef>
-              <a:spcAft>
-                <a:spcPts val="0"/>
-              </a:spcAft>
-              <a:buSzPts val="1800"/>
-              <a:buNone/>
-            </a:pPr>
-            <a:r>
-              <a:rPr lang="en" sz="1100" b="1">
-                <a:solidFill>
-                  <a:schemeClr val="dk1"/>
-                </a:solidFill>
-              </a:rPr>
-              <a:t>Long-Term Vision: </a:t>
-            </a:r>
-            <a:r>
-              <a:rPr lang="en" sz="1100">
-                <a:solidFill>
-                  <a:schemeClr val="dk1"/>
-                </a:solidFill>
-              </a:rPr>
-              <a:t>a student-built, barangay-owned network of units along connected creeks, feeding one open dataset that shows where plastic enters, which products dominate and whether EPR commitments change what the water carries. Planned upgrades are a belt conveyor for higher volumes and a second camera angle. Each barangay added makes every unit's data more valuable. The pilot proves the method at one creek and claims no more.</a:t>
-            </a:r>
-          </a:p>
-          <a:p>
-            <a:pPr indent="0" lvl="0" marL="0" rtl="0" algn="l">
-              <a:lnSpc>
-                <a:spcPct val="105000"/>
-              </a:lnSpc>
-              <a:spcBef>
-                <a:spcPts val="400"/>
-              </a:spcBef>
-              <a:spcAft>
-                <a:spcPts val="0"/>
-              </a:spcAft>
-              <a:buSzPts val="1800"/>
-              <a:buNone/>
-            </a:pPr>
-            <a:r>
-              <a:rPr lang="en" sz="1100" b="1">
-                <a:solidFill>
-                  <a:schemeClr val="dk1"/>
-                </a:solidFill>
-              </a:rPr>
-              <a:t>Key Takeaway: </a:t>
-            </a:r>
-            <a:r>
-              <a:rPr lang="en" sz="1100">
-                <a:solidFill>
-                  <a:schemeClr val="dk1"/>
-                </a:solidFill>
-              </a:rPr>
-              <a:t>The Philippines already knows who makes much of its plastic. SAGIP makes the proof continuous, cheap and community-owned, and lifts some of the plastic out along the way.</a:t>
-            </a:r>
+            <a:endParaRPr sz="1100">
+              <a:solidFill>
+                <a:schemeClr val="dk1"/>
+              </a:solidFill>
+            </a:endParaRPr>
           </a:p>
         </p:txBody>
       </p:sp>

</xml_diff>

<commit_message>
Rebuild entry, PPT and prototype design on the optimized SAGIP design; update handoff; move prior versions to old_versions
Co-Authored-By: Claude Sonnet 5.5 <noreply@anthropic.com>
Claude-Session: https://claude.ai/code/session_01BeuSv6ZfopDpEFLv7nhPKY
</commit_message>
<xml_diff>
--- a/sft_entry/SAGIP_SFT2026_Entry_PPT.pptx
+++ b/sft_entry/SAGIP_SFT2026_Entry_PPT.pptx
@@ -9693,7 +9693,7 @@
                   <a:schemeClr val="dk1"/>
                 </a:solidFill>
               </a:rPr>
-              <a:t>Our device is a low-cost, solar-powered unit that lifts floating plastic out of a creek and counts each item with a tiny on-chip AI model. Barangay officials get a weekly offline report of what was removed, plus a secondary water-level alert for blockages. Built for about PHP 6,000 from local parts, it adds anonymized records to an open dataset that other barangays can copy.</a:t>
+              <a:t>SAGIP is a low-cost, solar-powered unit that filters floating plastic out of a creek, lifts it into a sorted bin and names each item with a small on-chip image model. Barangay officials get a weekly offline report of what the creek carried, plus a secondary water-level alert for blockages. Built for about PHP 6,000 from local parts, it adds anonymized records to an open dataset that other barangays can copy.</a:t>
             </a:r>
             <a:endParaRPr i="1" sz="1100">
               <a:solidFill>
@@ -9817,7 +9817,7 @@
                   <a:schemeClr val="dk1"/>
                 </a:solidFill>
               </a:rPr>
-              <a:t>Philippine rivers rank among the largest sources of ocean plastic (Jambeck et al., 2015, Lebreton et al., 2017, Meijer et al., 2021), and small urban esteros feed them. Cleanups weigh bulk waste and record nothing about it. Brand audits are periodic and mostly land-based (Break Free From Plastic, 2019), and RA 11898 needs proof of which packaging reaches waterways. The gap is a continuous, low-cost record taken at the creek itself.</a:t>
+              <a:t>Philippine rivers rank among the largest sources of ocean plastic (Jambeck et al., 2015, Lebreton et al., 2017, Meijer et al., 2021). Cleanups weigh bulk waste and record nothing about it. Brand audits are periodic and mostly land-based (Break Free From Plastic, 2019), and RA 11898 needs proof of which packaging reaches waterways. The gap is a continuous, low-cost record taken at the creek itself.</a:t>
             </a:r>
             <a:endParaRPr sz="1100">
               <a:solidFill>
@@ -9920,7 +9920,7 @@
                   <a:schemeClr val="dk1"/>
                 </a:solidFill>
               </a:rPr>
-              <a:t>: (1) In an 8-week pilot from December 2026, lift at least [TARGET] kg of floating debris and capture at least [X]% of what reaches the boom. (2) By November 20, reach 85% precision and recall on unseen photos, with weekly counts within 15% of a hand audit. (3) By March 2027, publish an open dataset and build guide and help [2] more barangays or schools build a PHP 6,000 unit.</a:t>
+              <a:t>: (1) In an 8-week pilot from December 2026, capture at least 50% of the floating debris that reaches the boom, lift at least 20 kg and log at least 1,000 classified items. (2) By November 20, reach 85% precision and recall on unseen photos, with weekly counts within 15% of a hand audit. (3) By March 2027, publish an open dataset and build guide and help 2 more barangays or schools build a PHP 6,000 unit.</a:t>
             </a:r>
             <a:endParaRPr sz="1100">
               <a:solidFill>
@@ -9991,7 +9991,7 @@
                   <a:schemeClr val="dk1"/>
                 </a:solidFill>
               </a:rPr>
-              <a:t>the [N] households of [barangay and purok] along [estero] and the barangay sanitation officers. </a:t>
+              <a:t>the [N] households of [barangay and purok] along [estero site] in Quezon City and the barangay sanitation officers. </a:t>
             </a:r>
             <a:r>
               <a:rPr b="1" lang="en" sz="1100">
@@ -10007,7 +10007,7 @@
                   <a:schemeClr val="dk1"/>
                 </a:solidFill>
               </a:rPr>
-              <a:t>the city solid-waste office and DENR, [2] more barangays or schools, and downstream fisherfolk.</a:t>
+              <a:t>the city solid-waste office and DENR, 2 more barangays or schools, and downstream fisherfolk.</a:t>
             </a:r>
             <a:endParaRPr sz="1100">
               <a:solidFill>
@@ -10143,7 +10143,7 @@
                   <a:schemeClr val="dk1"/>
                 </a:solidFill>
               </a:rPr>
-              <a:t>We scored five community problems on significance, feasibility, STEM depth, replicability and originality. Creek plastic won. [Edit to match your process.]</a:t>
+              <a:t>We scored five community problems on significance, feasibility, STEM depth, replicability and originality. Creek plastic won, and we fitted the design to PHP 6,000. [Edit to match your process.]</a:t>
             </a:r>
             <a:endParaRPr b="1" sz="1100">
               <a:solidFill>
@@ -10183,7 +10183,7 @@
                   <a:schemeClr val="dk1"/>
                 </a:solidFill>
               </a:rPr>
-              <a:t>Cameras count floating plastic but remove nothing (van Lieshout et al., 2020). Robotic boats collect it but need radio and an operator (HydroSentinel, 2026). Trash traps and interceptors remove it in bulk with little item-level data (Manila Bulletin, 2026, Schmaltz et al., 2020). Brand audits name companies but are manual (Break Free From Plastic, 2019).</a:t>
+              <a:t>Cameras count floating plastic but remove nothing (van Lieshout et al., 2020). Solar Interceptor barriers and AI boats are planned or piloted on large Pasig-area rivers (The Ocean Cleanup, 2026, Manila Bulletin, 2025). Trash traps remove plastic in bulk and record only weight (Philstar, 2022). Brand audits name companies but are manual (Break Free From Plastic, 2019).</a:t>
             </a:r>
             <a:endParaRPr b="1" sz="1100">
               <a:solidFill>
@@ -10263,7 +10263,7 @@
                   <a:schemeClr val="dk1"/>
                 </a:solidFill>
               </a:rPr>
-              <a:t>Break Free From Plastic and GAIA 2019, Cordova &amp; Nurhati 2019, David et al. 2021, HydroSentinel 2026, Jacob et al. 2018, Jambeck et al. 2015, Lebreton et al. 2017, Manila Bulletin 2026, Meijer et al. 2021, RA 11898, Schmaltz et al. 2020, van Lieshout et al. 2020.</a:t>
+              <a:t>Break Free From Plastic 2019, Cordova &amp; Nurhati 2019, David et al. 2021, Jacob et al. 2018, Jambeck et al. 2015, Lebreton et al. 2017, Manila Bulletin 2025, Meijer et al. 2021, Philstar 2022, RA 11898, The Ocean Cleanup 2026, van Lieshout et al. 2020.</a:t>
             </a:r>
             <a:endParaRPr b="1" sz="1100">
               <a:solidFill>
@@ -10395,7 +10395,7 @@
                   <a:schemeClr val="dk1"/>
                 </a:solidFill>
               </a:rPr>
-              <a:t>A floating boom guides plastic to a bar screen, a camera-triggered arm lifts it into a bin, and an ESP32-S3 camera counts each item on the chip with an INT8 model (Jacob et al., 2018, David et al., 2021). An offline Wi-Fi page gives the barangay a weekly report and an open dataset. An ultrasonic sensor warns of rising water as a secondary function. A shear pin, current and Hall sensing and a three-retry lockout protect against jams.</a:t>
+              <a:t>A floating boom and hyacinth deflector guide plastic to coarse bars and a fine mesh basket. A rake arm lifts it up a ramp, a hooded camera runs a small 2D CNN on the chip (Jacob et al., 2018, David et al., 2021), and a servo gate drops plastic into Bin A and plants or unsure items into Bin B. An offline Wi-Fi page gives a weekly report and an open dataset, and an ultrasonic sensor warns of rising water.</a:t>
             </a:r>
             <a:endParaRPr b="1" sz="1100">
               <a:solidFill>
@@ -10431,7 +10431,7 @@
                   <a:schemeClr val="dk1"/>
                 </a:solidFill>
               </a:rPr>
-              <a:t>Physics sets buoyancy, torque and the solar budget. Mathematics defines precision, recall and count error. Computer science supplies the quantized model. Engineering joins them in a weatherproof floating structure.</a:t>
+              <a:t>Physics sets buoyancy, torque and the solar budget. Mathematics defines precision, recall and count error. Computer science supplies the quantized CNN. The motor slows under load, and a shear pin, current sensing and three retries stop jams.</a:t>
             </a:r>
             <a:endParaRPr b="1" sz="1100">
               <a:solidFill>
@@ -10627,7 +10627,7 @@
                   <a:schemeClr val="dk1"/>
                 </a:solidFill>
               </a:rPr>
-              <a:t> ESP32-S3 camera board 1,300, microSD 200, box 300, solar panel 600, charger and cells 700, boom and post 800, bin and gauge 150, wiring 250, level sensor 350, motor and driver 700, sensing 150, ramp and arm 150, contingency 350. Stages: bench 1,800, passive trap 2,500, arm and sensor 1,350. Timeline: model by Nov 20, results Dec 7, pilot Dec to Feb, guide by March.</a:t>
+              <a:t> ESP32-S3 camera, microSD, clock and enclosure 1,850, solar panel, charger and cells 1,200, boom, post, bins and wiring 1,100, level sensor 350, motor, driver, sensing and servo 1,000, ramp, arm and filters 350, contingency 150. Stages: bench 1,850, passive trap 2,650, arm and sorter 1,350. Timeline: model by Nov 20, results Dec 7, pilot Dec to Feb, guide by March.</a:t>
             </a:r>
             <a:endParaRPr sz="1100">
               <a:solidFill>
@@ -10699,7 +10699,7 @@
                   <a:schemeClr val="dk1"/>
                 </a:solidFill>
               </a:rPr>
-              <a:t> Hyacinth mats: deflector and a vegetation class that stops the arm. Jams: shear pin, current and Hall sensing, three retries. Oil and silt: motor mounted high, sealed bearings. Model errors: test on unseen places and keep the hand count. Arm failure: boom, bin and camera still work. Safety and privacy: no one enters the water and the camera sees water only.</a:t>
+              <a:t> Manual labor: weekly emptying, screen clearing and lens wiping, logged in hours. Hyacinth: deflector and a plant class. Jams: shear pin, current sensing, three retries. Water level: hinged floating ramp foot. Model errors: unsure items go to Bin B and a hand count checks. Safety and privacy: no one enters the water and the camera sees water only.</a:t>
             </a:r>
             <a:endParaRPr sz="1100">
               <a:solidFill>
@@ -10859,7 +10859,7 @@
                   <a:schemeClr val="dk1"/>
                 </a:solidFill>
               </a:rPr>
-              <a:t> (1) At least [TARGET] kg lifted in 8 weeks, with a capture rate of at least [X]% against a baseline week. (2) Weekly counts within 15% of the hand audit, and 85% precision and recall on unseen places. (3) At least [2] more sites by March 2027 at about PHP 6,000 each, sharing one open data format.</a:t>
+              <a:t> (1) At least 50% capture against a baseline week and 20 kg lifted in 8 weeks. (2) At least 1,000 classified items, weekly counts within 15% of the hand audit and 85% precision and recall on unseen places. (3) At least 2 more sites by March 2027 at about PHP 6,000 each, with weekly labor hours reported.</a:t>
             </a:r>
             <a:endParaRPr sz="1100">
               <a:solidFill>

</xml_diff>

<commit_message>
Hybrid floating-foot version at PHP 6,800, all references 2021 or later; previous files moved to old_versions
Co-Authored-By: Claude Sonnet 5.5 <noreply@anthropic.com>
Claude-Session: https://claude.ai/code/session_01BeuSv6ZfopDpEFLv7nhPKY
</commit_message>
<xml_diff>
--- a/sft_entry/SAGIP_SFT2026_Entry_PPT.pptx
+++ b/sft_entry/SAGIP_SFT2026_Entry_PPT.pptx
@@ -9693,7 +9693,7 @@
                   <a:schemeClr val="dk1"/>
                 </a:solidFill>
               </a:rPr>
-              <a:t>SAGIP is a low-cost, solar-powered unit that filters floating plastic out of a creek, lifts it into a sorted bin and names each item with a small on-chip image model. Barangay officials get a weekly offline report of what the creek carried, plus a secondary water-level alert for blockages. Built for about PHP 6,000 from local parts, it adds anonymized records to an open dataset that other barangays can copy.</a:t>
+              <a:t>SAGIP is a low-cost, solar-powered unit that filters floating plastic out of a creek, lifts it into a sorted bin and names each item with a small on-chip image model. Barangay officials get a weekly offline report of what the creek carried, plus a secondary water-level alert for blockages. Built for about PHP 6,800 from local parts, it adds anonymized records to an open dataset that other barangays can copy.</a:t>
             </a:r>
             <a:endParaRPr i="1" sz="1100">
               <a:solidFill>
@@ -9817,7 +9817,7 @@
                   <a:schemeClr val="dk1"/>
                 </a:solidFill>
               </a:rPr>
-              <a:t>Philippine rivers rank among the largest sources of ocean plastic (Jambeck et al., 2015, Lebreton et al., 2017, Meijer et al., 2021). Cleanups weigh bulk waste and record nothing about it. Brand audits are periodic and mostly land-based (Break Free From Plastic, 2019), and RA 11898 needs proof of which packaging reaches waterways. The gap is a continuous, low-cost record taken at the creek itself.</a:t>
+              <a:t>Philippine rivers rank first among countries for river plastic emissions (Meijer et al., 2021). Cleanups weigh bulk waste and record nothing about it. Brand audits are periodic and mostly land-based (Break Free From Plastic, 2021), and RA 11898 needs proof of which packaging reaches waterways. The gap is a continuous, low-cost record taken at the creek itself.</a:t>
             </a:r>
             <a:endParaRPr sz="1100">
               <a:solidFill>
@@ -9920,7 +9920,7 @@
                   <a:schemeClr val="dk1"/>
                 </a:solidFill>
               </a:rPr>
-              <a:t>: (1) In an 8-week pilot from December 2026, capture at least 50% of the floating debris that reaches the boom, lift at least 20 kg and log at least 1,000 classified items. (2) By November 20, reach 85% precision and recall on unseen photos, with weekly counts within 15% of a hand audit. (3) By March 2027, publish an open dataset and build guide and help 2 more barangays or schools build a PHP 6,000 unit.</a:t>
+              <a:t>: (1) In an 8-week pilot from December 2026, capture at least 50% of the floating debris that reaches the boom, lift at least 20 kg and log at least 1,000 classified items. (2) By November 20, reach 85% precision and recall on unseen photos, with weekly counts within 15% of a hand audit. (3) By March 2027, publish an open dataset and build guide and help 2 more barangays or schools build a PHP 6,800 unit.</a:t>
             </a:r>
             <a:endParaRPr sz="1100">
               <a:solidFill>
@@ -10143,7 +10143,7 @@
                   <a:schemeClr val="dk1"/>
                 </a:solidFill>
               </a:rPr>
-              <a:t>We scored five community problems on significance, feasibility, STEM depth, replicability and originality. Creek plastic won, and we fitted the design to PHP 6,000. [Edit to match your process.]</a:t>
+              <a:t>We scored five community problems on significance, feasibility, STEM depth, replicability and originality. Creek plastic won, and we fitted the design to PHP 6,800. [Edit to match your process.]</a:t>
             </a:r>
             <a:endParaRPr b="1" sz="1100">
               <a:solidFill>
@@ -10183,7 +10183,7 @@
                   <a:schemeClr val="dk1"/>
                 </a:solidFill>
               </a:rPr>
-              <a:t>Cameras count floating plastic but remove nothing (van Lieshout et al., 2020). Solar Interceptor barriers and AI boats are planned or piloted on large Pasig-area rivers (The Ocean Cleanup, 2026, Manila Bulletin, 2025). Trash traps remove plastic in bulk and record only weight (Philstar, 2022). Brand audits name companies but are manual (Break Free From Plastic, 2019).</a:t>
+              <a:t>Cameras detect floating plastic but remove nothing (Kataoka et al., 2024). Solar Interceptor barriers and AI boats are planned or piloted on large Pasig-area rivers (The Ocean Cleanup, 2026, Manila Bulletin, 2025). Trash traps remove plastic in bulk and record only weight (Philstar, 2022). Brand audits name companies but are manual (Break Free From Plastic, 2021).</a:t>
             </a:r>
             <a:endParaRPr b="1" sz="1100">
               <a:solidFill>
@@ -10223,7 +10223,7 @@
                   <a:schemeClr val="dk1"/>
                 </a:solidFill>
               </a:rPr>
-              <a:t>No system we found lifts, counts and shares open data at barangay cost. Can a PHP 6,000 on-chip counter match a hand audit within 15%, and does continuous counting show rain-driven pulses of plastic (Cordova &amp; Nurhati, 2019) that weekly audits miss?</a:t>
+              <a:t>No system we found lifts, counts and shares open data at barangay cost. Can a PHP 6,800 on-chip counter match a hand audit within 15%, and does continuous counting show rain-driven pulses of plastic (van Emmerik et al., 2022) that weekly audits miss?</a:t>
             </a:r>
             <a:endParaRPr b="1" sz="1100">
               <a:solidFill>
@@ -10263,7 +10263,7 @@
                   <a:schemeClr val="dk1"/>
                 </a:solidFill>
               </a:rPr>
-              <a:t>Break Free From Plastic 2019, Cordova &amp; Nurhati 2019, David et al. 2021, Jacob et al. 2018, Jambeck et al. 2015, Lebreton et al. 2017, Manila Bulletin 2025, Meijer et al. 2021, Philstar 2022, RA 11898, The Ocean Cleanup 2026, van Lieshout et al. 2020.</a:t>
+              <a:t>Break Free From Plastic 2021, David et al. 2021, Gholami et al. 2021, Kataoka et al. 2024, Manila Bulletin 2025, Meijer et al. 2021, Philstar 2022, RA 11898, The Ocean Cleanup 2026, van Emmerik et al. 2022.</a:t>
             </a:r>
             <a:endParaRPr b="1" sz="1100">
               <a:solidFill>
@@ -10395,7 +10395,7 @@
                   <a:schemeClr val="dk1"/>
                 </a:solidFill>
               </a:rPr>
-              <a:t>A floating boom and hyacinth deflector guide plastic to coarse bars and a fine mesh basket. A rake arm lifts it up a ramp, a hooded camera runs a small 2D CNN on the chip (Jacob et al., 2018, David et al., 2021), and a servo gate drops plastic into Bin A and plants or unsure items into Bin B. An offline Wi-Fi page gives a weekly report and an open dataset, and an ultrasonic sensor warns of rising water.</a:t>
+              <a:t>A floating boom and hyacinth deflector guide plastic to coarse bars and a fine mesh basket. A rake arm lifts it up a ramp whose foot floats on bottles, a hooded camera runs a small 2D CNN on the chip (Gholami et al., 2021, David et al., 2021), and a servo gate drops plastic into Bin A and plants or unsure items into Bin B. An offline Wi-Fi page gives a weekly report and an open dataset, and an ultrasonic sensor warns of rising water.</a:t>
             </a:r>
             <a:endParaRPr b="1" sz="1100">
               <a:solidFill>
@@ -10591,7 +10591,7 @@
                   <a:schemeClr val="dk1"/>
                 </a:solidFill>
               </a:rPr>
-              <a:t>A pilot unit costs about PHP 6,000, built in three stages that are each bought only after the previous test passes.</a:t>
+              <a:t>A pilot unit costs about PHP 6,800, built in three stages that are each bought only after the previous test passes.</a:t>
             </a:r>
             <a:endParaRPr sz="1100">
               <a:solidFill>
@@ -10627,7 +10627,7 @@
                   <a:schemeClr val="dk1"/>
                 </a:solidFill>
               </a:rPr>
-              <a:t> ESP32-S3 camera, microSD, clock and enclosure 1,850, solar panel, charger and cells 1,200, boom, post, bins and wiring 1,100, level sensor 350, motor, driver, sensing and servo 1,000, ramp, arm and filters 350, contingency 150. Stages: bench 1,850, passive trap 2,650, arm and sorter 1,350. Timeline: model by Nov 20, results Dec 7, pilot Dec to Feb, guide by March.</a:t>
+              <a:t> ESP32-S3 camera, microSD, clock and enclosure 1,850, solar panel, charger and cells 1,200, boom, post, bins and wiring 1,100, level sensor 350, motor, driver, sensing and servo 1,000, ramp, arm and filters 350, hinged float foot and chute 600, contingency 350. Stages: bench 1,850, passive trap 3,250, arm and sorter 1,350. Timeline: model by Nov 20, results Dec 7, pilot Dec to Feb, guide by March.</a:t>
             </a:r>
             <a:endParaRPr sz="1100">
               <a:solidFill>
@@ -10699,7 +10699,7 @@
                   <a:schemeClr val="dk1"/>
                 </a:solidFill>
               </a:rPr>
-              <a:t> Manual labor: weekly emptying, screen clearing and lens wiping, logged in hours. Hyacinth: deflector and a plant class. Jams: shear pin, current sensing, three retries. Water level: hinged floating ramp foot. Model errors: unsure items go to Bin B and a hand count checks. Safety and privacy: no one enters the water and the camera sees water only.</a:t>
+              <a:t> Manual labor: weekly emptying, screen clearing and lens wiping, logged in hours. Hyacinth: deflector and a plant class. Jams: shear pin, current sensing, three retries. Water level: hinged floating ramp foot with a flexible chute. Model errors: unsure items go to Bin B and a hand count checks. Safety and privacy: no one enters the water and the camera sees water only.</a:t>
             </a:r>
             <a:endParaRPr sz="1100">
               <a:solidFill>
@@ -10859,7 +10859,7 @@
                   <a:schemeClr val="dk1"/>
                 </a:solidFill>
               </a:rPr>
-              <a:t> (1) At least 50% capture against a baseline week and 20 kg lifted in 8 weeks. (2) At least 1,000 classified items, weekly counts within 15% of the hand audit and 85% precision and recall on unseen places. (3) At least 2 more sites by March 2027 at about PHP 6,000 each, with weekly labor hours reported.</a:t>
+              <a:t> (1) At least 50% capture against a baseline week and 20 kg lifted in 8 weeks. (2) At least 1,000 classified items, weekly counts within 15% of the hand audit and 85% precision and recall on unseen places. (3) At least 2 more sites by March 2027 at about PHP 6,800 each, with weekly labor hours reported.</a:t>
             </a:r>
             <a:endParaRPr sz="1100">
               <a:solidFill>

</xml_diff>

<commit_message>
Fully floating version at PHP 12,000: raft on four drums with mooring, rebuilt entry, PPT, prototype design and drawings; hybrid versions kept in old_versions
Co-Authored-By: Claude Sonnet 5.5 <noreply@anthropic.com>
Claude-Session: https://claude.ai/code/session_01BeuSv6ZfopDpEFLv7nhPKY
</commit_message>
<xml_diff>
--- a/sft_entry/SAGIP_SFT2026_Entry_PPT.pptx
+++ b/sft_entry/SAGIP_SFT2026_Entry_PPT.pptx
@@ -9514,7 +9514,7 @@
             </a:pPr>
             <a:r>
               <a:rPr b="1" lang="en" sz="2600"/>
-              <a:t>SAGIP: Solar-Powered Estero Guardian with On-Chip AI</a:t>
+              <a:t>SAGIP: Floating Solar-Powered Estero Guardian with On-Chip AI</a:t>
             </a:r>
             <a:endParaRPr b="1" sz="2600"/>
           </a:p>
@@ -9693,7 +9693,7 @@
                   <a:schemeClr val="dk1"/>
                 </a:solidFill>
               </a:rPr>
-              <a:t>SAGIP is a low-cost, solar-powered unit that filters floating plastic out of a creek, lifts it into a sorted bin and names each item with a small on-chip image model. Barangay officials get a weekly offline report of what the creek carried, plus a secondary water-level alert for blockages. Built for about PHP 6,800 from local parts, it adds anonymized records to an open dataset that other barangays can copy.</a:t>
+              <a:t>SAGIP is a low-cost, floating, solar-powered raft that filters plastic out of a creek, lifts it into a sorted bin and names each item with a small on-chip image model. Barangay officials get a weekly offline report of what the creek carried, plus a secondary water-level alert for blockages. Built for about PHP 12,000 from local parts, it adds anonymized records to an open dataset that other barangays can copy.</a:t>
             </a:r>
             <a:endParaRPr i="1" sz="1100">
               <a:solidFill>
@@ -9920,7 +9920,7 @@
                   <a:schemeClr val="dk1"/>
                 </a:solidFill>
               </a:rPr>
-              <a:t>: (1) In an 8-week pilot from December 2026, capture at least 50% of the floating debris that reaches the boom, lift at least 20 kg and log at least 1,000 classified items. (2) By November 20, reach 85% precision and recall on unseen photos, with weekly counts within 15% of a hand audit. (3) By March 2027, publish an open dataset and build guide and help 2 more barangays or schools build a PHP 6,800 unit.</a:t>
+              <a:t>: (1) In an 8-week pilot from December 2026, capture at least 50% of the floating debris that reaches the boom, lift at least 20 kg and log at least 1,000 classified items. (2) By November 20, reach 85% precision and recall on unseen photos, with weekly counts within 15% of a hand audit. (3) By March 2027, publish an open dataset and build guide and help 2 more barangays or schools build a PHP 12,000 unit.</a:t>
             </a:r>
             <a:endParaRPr sz="1100">
               <a:solidFill>
@@ -10143,7 +10143,7 @@
                   <a:schemeClr val="dk1"/>
                 </a:solidFill>
               </a:rPr>
-              <a:t>We scored five community problems on significance, feasibility, STEM depth, replicability and originality. Creek plastic won, and we fitted the design to PHP 6,800. [Edit to match your process.]</a:t>
+              <a:t>We scored five community problems on significance, feasibility, STEM depth, replicability and originality. Creek plastic won, and we fitted the design to PHP 12,000. [Edit to match your process.]</a:t>
             </a:r>
             <a:endParaRPr b="1" sz="1100">
               <a:solidFill>
@@ -10223,7 +10223,7 @@
                   <a:schemeClr val="dk1"/>
                 </a:solidFill>
               </a:rPr>
-              <a:t>No system we found lifts, counts and shares open data at barangay cost. Can a PHP 6,800 on-chip counter match a hand audit within 15%, and does continuous counting show rain-driven pulses of plastic (van Emmerik et al., 2022) that weekly audits miss?</a:t>
+              <a:t>No system we found lifts, counts and shares open data at barangay cost. Can a PHP 12,000 on-chip counter match a hand audit within 15%, and does continuous counting show rain-driven pulses of plastic (van Emmerik et al., 2022) that weekly audits miss?</a:t>
             </a:r>
             <a:endParaRPr b="1" sz="1100">
               <a:solidFill>
@@ -10395,7 +10395,7 @@
                   <a:schemeClr val="dk1"/>
                 </a:solidFill>
               </a:rPr>
-              <a:t>A floating boom and hyacinth deflector guide plastic to coarse bars and a fine mesh basket. A rake arm lifts it up a ramp whose foot floats on bottles, a hooded camera runs a small 2D CNN on the chip (Gholami et al., 2021, David et al., 2021), and a servo gate drops plastic into Bin A and plants or unsure items into Bin B. An offline Wi-Fi page gives a weekly report and an open dataset, and an ultrasonic sensor warns of rising water.</a:t>
+              <a:t>A boom and hyacinth deflector guide plastic to a floating, moored solar raft, where coarse bars and a fine mesh basket catch it. A rake arm lifts it up a ramp, a hooded camera runs a small 2D CNN on the chip (Gholami et al., 2021, David et al., 2021), and a servo gate drops plastic into Bin A and plants or unsure items into Bin B. An offline Wi-Fi page gives a weekly report and an open dataset, and an ultrasonic sensor warns of rising water.</a:t>
             </a:r>
             <a:endParaRPr b="1" sz="1100">
               <a:solidFill>
@@ -10431,7 +10431,7 @@
                   <a:schemeClr val="dk1"/>
                 </a:solidFill>
               </a:rPr>
-              <a:t>Physics sets buoyancy, torque and the solar budget. Mathematics defines precision, recall and count error. Computer science supplies the quantized CNN. The motor slows under load, and a shear pin, current sensing and three retries stop jams.</a:t>
+              <a:t>Physics sets the raft's buoyancy, torque and the solar budget. Mathematics defines precision, recall and count error. Computer science supplies the quantized CNN. The motor slows under load, and a shear pin, current sensing and three retries stop jams.</a:t>
             </a:r>
             <a:endParaRPr b="1" sz="1100">
               <a:solidFill>
@@ -10591,7 +10591,7 @@
                   <a:schemeClr val="dk1"/>
                 </a:solidFill>
               </a:rPr>
-              <a:t>A pilot unit costs about PHP 6,800, built in three stages that are each bought only after the previous test passes.</a:t>
+              <a:t>A pilot unit costs about PHP 12,000, built in three stages that are each bought only after the previous test passes.</a:t>
             </a:r>
             <a:endParaRPr sz="1100">
               <a:solidFill>
@@ -10627,7 +10627,7 @@
                   <a:schemeClr val="dk1"/>
                 </a:solidFill>
               </a:rPr>
-              <a:t> ESP32-S3 camera, microSD, clock and enclosure 1,850, solar panel, charger and cells 1,200, boom, post, bins and wiring 1,100, level sensor 350, motor, driver, sensing and servo 1,000, ramp, arm and filters 350, hinged float foot and chute 600, contingency 350. Stages: bench 1,850, passive trap 3,250, arm and sorter 1,350. Timeline: model by Nov 20, results Dec 7, pilot Dec to Feb, guide by March.</a:t>
+              <a:t> ESP32-S3 camera, microSD, clock and enclosure 1,850, 10 W solar panel, charger and cells 1,400, wiring, bins and gauge 400, level sensor 350, motor, driver, sensing and servo 1,000, ramp, arm and filters 500, drums 2,000, deck 1,900, boom 600, mooring 900, hardware 600, contingency 500. Stages: bench 1,850, raft and passive trap 8,150, arm and sorter 1,500. Timeline: model by Nov 20, results Dec 7, pilot Dec to Feb, guide by March.</a:t>
             </a:r>
             <a:endParaRPr sz="1100">
               <a:solidFill>
@@ -10699,7 +10699,7 @@
                   <a:schemeClr val="dk1"/>
                 </a:solidFill>
               </a:rPr>
-              <a:t> Manual labor: weekly emptying, screen clearing and lens wiping, logged in hours. Hyacinth: deflector and a plant class. Jams: shear pin, current sensing, three retries. Water level: hinged floating ramp foot with a flexible chute. Model errors: unsure items go to Bin B and a hand count checks. Safety and privacy: no one enters the water and the camera sees water only.</a:t>
+              <a:t> Manual labor: weekly emptying, screen clearing and lens wiping, logged in hours. Hyacinth: deflector and a plant class. Jams: shear pin, current sensing, three retries. Raft stability: pond test, two mooring lines, hauled ashore before storms. Channel: one side only, with barangay and city approval. Model errors: unsure items go to Bin B and a hand count checks. Safety: no one boards the raft.</a:t>
             </a:r>
             <a:endParaRPr sz="1100">
               <a:solidFill>
@@ -10859,7 +10859,7 @@
                   <a:schemeClr val="dk1"/>
                 </a:solidFill>
               </a:rPr>
-              <a:t> (1) At least 50% capture against a baseline week and 20 kg lifted in 8 weeks. (2) At least 1,000 classified items, weekly counts within 15% of the hand audit and 85% precision and recall on unseen places. (3) At least 2 more sites by March 2027 at about PHP 6,800 each, with weekly labor hours reported.</a:t>
+              <a:t> (1) At least 50% capture against a baseline week and 20 kg lifted in 8 weeks. (2) At least 1,000 classified items, weekly counts within 15% of the hand audit and 85% precision and recall on unseen places. (3) At least 2 more sites by March 2027 at about PHP 12,000 each, with weekly labor hours reported.</a:t>
             </a:r>
             <a:endParaRPr sz="1100">
               <a:solidFill>

</xml_diff>

<commit_message>
Strengthen background research: Pasig model ranking, on-chip classifier prior art with lab-to-field gap; previous float version kept in old_versions
Co-Authored-By: Claude Sonnet 5.5 <noreply@anthropic.com>
Claude-Session: https://claude.ai/code/session_01BeuSv6ZfopDpEFLv7nhPKY
</commit_message>
<xml_diff>
--- a/sft_entry/SAGIP_SFT2026_Entry_PPT.pptx
+++ b/sft_entry/SAGIP_SFT2026_Entry_PPT.pptx
@@ -9817,7 +9817,7 @@
                   <a:schemeClr val="dk1"/>
                 </a:solidFill>
               </a:rPr>
-              <a:t>Philippine rivers rank first among countries for river plastic emissions (Meijer et al., 2021). Cleanups weigh bulk waste and record nothing about it. Brand audits are periodic and mostly land-based (Break Free From Plastic, 2021), and RA 11898 needs proof of which packaging reaches waterways. The gap is a continuous, low-cost record taken at the creek itself.</a:t>
+              <a:t>Philippine rivers rank first among countries for river plastic emissions, with the Pasig first among rivers in the model (Meijer et al., 2021). Cleanups weigh bulk waste and record nothing about it. Brand audits are periodic and mostly land-based (Break Free From Plastic, 2021), and RA 11898 needs proof of which packaging reaches waterways. The gap is a continuous, low-cost record taken at the creek itself.</a:t>
             </a:r>
             <a:endParaRPr sz="1100">
               <a:solidFill>
@@ -10143,7 +10143,7 @@
                   <a:schemeClr val="dk1"/>
                 </a:solidFill>
               </a:rPr>
-              <a:t>We scored five community problems on significance, feasibility, STEM depth, replicability and originality. Creek plastic won, and we fitted the design to PHP 12,000. [Edit to match your process.]</a:t>
+              <a:t>We scored five community problems on significance, feasibility, STEM depth, replicability and originality. Creek plastic won. [Edit to match your process.]</a:t>
             </a:r>
             <a:endParaRPr b="1" sz="1100">
               <a:solidFill>
@@ -10183,7 +10183,7 @@
                   <a:schemeClr val="dk1"/>
                 </a:solidFill>
               </a:rPr>
-              <a:t>Cameras detect floating plastic but remove nothing (Kataoka et al., 2024). Solar Interceptor barriers and AI boats are planned or piloted on large Pasig-area rivers (The Ocean Cleanup, 2026, Manila Bulletin, 2025). Trash traps remove plastic in bulk and record only weight (Philstar, 2022). Brand audits name companies but are manual (Break Free From Plastic, 2021).</a:t>
+              <a:t>Cameras detect floating plastic but remove nothing (Kataoka et al., 2024). Solar Interceptor barriers and AI boats are planned or piloted on large Pasig-area rivers (The Ocean Cleanup, 2026, Manila Bulletin, 2025). Trash traps remove plastic in bulk and record only weight (Philstar, 2022). Brand audits are manual (Break Free From Plastic, 2021). Tiny on-chip classifiers have only had controlled tests (Mendez-Cruz et al., 2024).</a:t>
             </a:r>
             <a:endParaRPr b="1" sz="1100">
               <a:solidFill>
@@ -10263,7 +10263,7 @@
                   <a:schemeClr val="dk1"/>
                 </a:solidFill>
               </a:rPr>
-              <a:t>Break Free From Plastic 2021, David et al. 2021, Gholami et al. 2021, Kataoka et al. 2024, Manila Bulletin 2025, Meijer et al. 2021, Philstar 2022, RA 11898, The Ocean Cleanup 2026, van Emmerik et al. 2022.</a:t>
+              <a:t>Break Free From Plastic 2021, David et al. 2021, Gholami et al. 2021, Kataoka et al. 2024, Manila Bulletin 2025, Meijer et al. 2021, Mendez-Cruz et al. 2024, Philstar 2022, RA 11898, The Ocean Cleanup 2026, van Emmerik et al. 2022.</a:t>
             </a:r>
             <a:endParaRPr b="1" sz="1100">
               <a:solidFill>

</xml_diff>

<commit_message>
DRAFT v7: autonomous solar skimmer boat with plastic accounting and flood node; judging-aware timeline; previous raft versions moved to old_versions
Co-Authored-By: Claude Sonnet 5.5 <noreply@anthropic.com>
Claude-Session: https://claude.ai/code/session_01BeuSv6ZfopDpEFLv7nhPKY
</commit_message>
<xml_diff>
--- a/sft_entry/SAGIP_SFT2026_Entry_PPT.pptx
+++ b/sft_entry/SAGIP_SFT2026_Entry_PPT.pptx
@@ -9514,7 +9514,7 @@
             </a:pPr>
             <a:r>
               <a:rPr b="1" lang="en" sz="2600"/>
-              <a:t>SAGIP: Floating Solar-Powered Estero Guardian with On-Chip AI</a:t>
+              <a:t>SAGIP: Autonomous Solar Skimmer Boat with On-Chip AI</a:t>
             </a:r>
             <a:endParaRPr b="1" sz="2600"/>
           </a:p>
@@ -9693,7 +9693,7 @@
                   <a:schemeClr val="dk1"/>
                 </a:solidFill>
               </a:rPr>
-              <a:t>SAGIP is a low-cost, floating, solar-powered raft that filters plastic out of a creek, lifts it into a sorted bin and names each item with a small on-chip image model. Barangay officials get a weekly offline report of what the creek carried, plus a secondary water-level alert for blockages. Built for about PHP 12,000 from local parts, it adds anonymized records to an open dataset that other barangays can copy.</a:t>
+              <a:t>SAGIP is a low-cost, solar-powered robot boat that patrols a creek, goes to floating debris, lifts it onto a conveyor and names each item with a small on-chip image model. Barangay officials get a weekly offline report of the plastic collected by type and weight, plus a float-switch flood alarm at the bank. Built for about PHP 16,000 from local parts, it adds anonymized records to an open dataset that other barangays can copy.</a:t>
             </a:r>
             <a:endParaRPr i="1" sz="1100">
               <a:solidFill>
@@ -9920,7 +9920,7 @@
                   <a:schemeClr val="dk1"/>
                 </a:solidFill>
               </a:rPr>
-              <a:t>: (1) In an 8-week pilot from December 2026, capture at least 50% of the floating debris that reaches the boom, lift at least 20 kg and log at least 1,000 classified items. (2) By November 20, reach 85% precision and recall on unseen photos, with weekly counts within 15% of a hand audit. (3) By March 2027, publish an open dataset and build guide and help 2 more barangays or schools build a PHP 12,000 unit.</a:t>
+              <a:t>: (1) In an 8-week pilot from January 2027, remove at least 50% of the floating debris entering a 30 m patrol stretch, lift at least 20 kg and log at least 1,000 classified items. (2) By December 5, reach 85% precision and recall on unseen photos, with weekly counts within 15% of a hand audit. (3) By March 2027, publish an open dataset and build guide and help 2 more barangays or schools build a PHP 16,000 unit.</a:t>
             </a:r>
             <a:endParaRPr sz="1100">
               <a:solidFill>
@@ -9991,7 +9991,7 @@
                   <a:schemeClr val="dk1"/>
                 </a:solidFill>
               </a:rPr>
-              <a:t>the [N] households of [barangay and purok] along [estero site] in Quezon City and the barangay sanitation officers. </a:t>
+              <a:t>the [N] households of [barangay and purok] along [estero site] in Quezon City, who also gain a flood alarm, and the barangay sanitation officers. </a:t>
             </a:r>
             <a:r>
               <a:rPr b="1" lang="en" sz="1100">
@@ -10183,7 +10183,7 @@
                   <a:schemeClr val="dk1"/>
                 </a:solidFill>
               </a:rPr>
-              <a:t>Cameras detect floating plastic but remove nothing (Kataoka et al., 2024). Solar Interceptor barriers and AI boats are planned or piloted on large Pasig-area rivers (The Ocean Cleanup, 2026, Manila Bulletin, 2025). Trash traps remove plastic in bulk and record only weight (Philstar, 2022). Brand audits are manual (Break Free From Plastic, 2021). Tiny on-chip classifiers have only had controlled tests (Mendez-Cruz et al., 2024).</a:t>
+              <a:t>Cameras detect floating plastic but remove nothing (Kataoka et al., 2024). Solar Interceptor barriers and an AI boat are planned or piloted on large Pasig-area rivers (The Ocean Cleanup, 2026, Manila Bulletin, 2025). Trash traps record only weight (Philstar, 2022). Brand audits are manual (Break Free From Plastic, 2021). Tiny on-chip classifiers have only had controlled tests (Mendez-Cruz et al., 2024).</a:t>
             </a:r>
             <a:endParaRPr b="1" sz="1100">
               <a:solidFill>
@@ -10223,7 +10223,7 @@
                   <a:schemeClr val="dk1"/>
                 </a:solidFill>
               </a:rPr>
-              <a:t>No system we found lifts, counts and shares open data at barangay cost. Can a PHP 12,000 on-chip counter match a hand audit within 15%, and does continuous counting show rain-driven pulses of plastic (van Emmerik et al., 2022) that weekly audits miss?</a:t>
+              <a:t>No system we found patrols a creek, collects plastic, counts it item by item and shares open data at barangay cost. Can a PHP 16,000 robot boat match a hand audit within 15%, and does continuous counting show rain-driven pulses of plastic (van Emmerik et al., 2022) that weekly audits miss?</a:t>
             </a:r>
             <a:endParaRPr b="1" sz="1100">
               <a:solidFill>
@@ -10376,7 +10376,7 @@
                 <a:spcPts val="1200"/>
               </a:spcBef>
               <a:spcAft>
-                <a:spcPts val="0"/>
+                <a:spcPts val="1200"/>
               </a:spcAft>
               <a:buSzPts val="1800"/>
               <a:buNone/>
@@ -10395,7 +10395,7 @@
                   <a:schemeClr val="dk1"/>
                 </a:solidFill>
               </a:rPr>
-              <a:t>A boom and hyacinth deflector guide plastic to a floating, moored solar raft, where coarse bars and a fine mesh basket catch it. A rake arm lifts it up a ramp, a hooded camera runs a small 2D CNN on the chip (Gholami et al., 2021, David et al., 2021), and a servo gate drops plastic into Bin A and plants or unsure items into Bin B. An offline Wi-Fi page gives a weekly report and an open dataset, and an ultrasonic sensor warns of rising water.</a:t>
+              <a:t>A solar-charged robot boat patrols the creek between two barriers. A bow camera spots floating debris, the boat steers to it, and a scoop lifts it onto a conveyor where a second camera runs a small 2D CNN (Gholami et al., 2021, David et al., 2021). A servo gate drops plastic into Bin A and plants or unsure items into Bin B. A weekly offline report gives counts, estimated kilograms and recovery value, and a float-switch flood alarm at the bank keeps the boat docked in rising water.</a:t>
             </a:r>
             <a:endParaRPr b="1" sz="1100">
               <a:solidFill>
@@ -10412,7 +10412,7 @@
                 <a:spcPts val="1200"/>
               </a:spcBef>
               <a:spcAft>
-                <a:spcPts val="0"/>
+                <a:spcPts val="1200"/>
               </a:spcAft>
               <a:buSzPts val="1800"/>
               <a:buNone/>
@@ -10431,7 +10431,7 @@
                   <a:schemeClr val="dk1"/>
                 </a:solidFill>
               </a:rPr>
-              <a:t>Physics sets the raft's buoyancy, torque and the solar budget. Mathematics defines precision, recall and count error. Computer science supplies the quantized CNN. The motor slows under load, and a shear pin, current sensing and three retries stop jams.</a:t>
+              <a:t>Physics sets the hull's buoyancy, thrust and the solar budget. Mathematics defines precision, recall and count error. Computer science supplies the detector and the quantized CNN. Engineering joins them in a weatherproof boat.</a:t>
             </a:r>
             <a:endParaRPr b="1" sz="1100">
               <a:solidFill>
@@ -10467,7 +10467,7 @@
                   <a:schemeClr val="dk1"/>
                 </a:solidFill>
               </a:rPr>
-              <a:t>Proof of what plastic reaches a creek can be continuous, cheap and community-owned, and one chip delivers cleanup and evidence together.</a:t>
+              <a:t>Proof of what plastic reaches a creek can be continuous, cheap and community-owned, and one robot collects and counts it.</a:t>
             </a:r>
             <a:endParaRPr b="1" sz="1100">
               <a:solidFill>
@@ -10591,7 +10591,7 @@
                   <a:schemeClr val="dk1"/>
                 </a:solidFill>
               </a:rPr>
-              <a:t>A pilot unit costs about PHP 12,000, built in three stages that are each bought only after the previous test passes.</a:t>
+              <a:t>A pilot unit costs about PHP 16,000, built in three stages that are each bought only after the previous test passes.</a:t>
             </a:r>
             <a:endParaRPr sz="1100">
               <a:solidFill>
@@ -10627,7 +10627,7 @@
                   <a:schemeClr val="dk1"/>
                 </a:solidFill>
               </a:rPr>
-              <a:t> ESP32-S3 camera, microSD, clock and enclosure 1,850, 10 W solar panel, charger and cells 1,400, wiring, bins and gauge 400, level sensor 350, motor, driver, sensing and servo 1,000, ramp, arm and filters 500, drums 2,000, deck 1,900, boom 600, mooring 900, hardware 600, contingency 500. Stages: bench 1,850, raft and passive trap 8,150, arm and sorter 1,500. Timeline: model by Nov 20, results Dec 7, pilot Dec to Feb, guide by March.</a:t>
+              <a:t> floats, frame and deck 2,300, thrusters 1,800, conveyor 2,000, ESP32-S3 camera set 1,850, bow detector 600, sensors 900, gate and bins 300, battery and wiring 2,400, 30 W panel 1,100, hardware 500, flood node 1,000, dock and barriers 600, contingency 650. Stages: bench 7,650, boat 6,100, dock and flood node 1,600. Timeline: screening Nov 9 to 13, mentorship Nov 16 to Dec 5, pitch Dec 7, creek pilot Jan to Feb.</a:t>
             </a:r>
             <a:endParaRPr sz="1100">
               <a:solidFill>
@@ -10663,7 +10663,7 @@
                   <a:schemeClr val="dk1"/>
                 </a:solidFill>
               </a:rPr>
-              <a:t> barangay captain and sanitation officers (site approval, weekly emptying, one-page agreement), city solid-waste office and DENR (use the data), adviser and school head (supervision, safety), and residents (consent).</a:t>
+              <a:t> barangay captain and sanitation officers (site approval, bin emptying, flood alarm, one-page agreement), city solid-waste office and DENR (use the data), adviser and school head (supervision, safety), and residents (consent).</a:t>
             </a:r>
             <a:endParaRPr sz="1100">
               <a:solidFill>
@@ -10699,7 +10699,7 @@
                   <a:schemeClr val="dk1"/>
                 </a:solidFill>
               </a:rPr>
-              <a:t> Manual labor: weekly emptying, screen clearing and lens wiping, logged in hours. Hyacinth: deflector and a plant class. Jams: shear pin, current sensing, three retries. Raft stability: pond test, two mooring lines, hauled ashore before storms. Channel: one side only, with barangay and city approval. Model errors: unsure items go to Bin B and a hand count checks. Safety: no one boards the raft.</a:t>
+              <a:t> Manual labor: bin emptying and snag clearing, logged in hours. Stability: foam-filled floats, tilt cut-off, pond tests. Navigation: barriers, side sensors, compass and phone remote. Hyacinth: plant class and shrouded propellers. Fast water: stays docked. Permission: barangay and city approval.</a:t>
             </a:r>
             <a:endParaRPr sz="1100">
               <a:solidFill>
@@ -10823,7 +10823,7 @@
                   <a:schemeClr val="dk1"/>
                 </a:solidFill>
               </a:rPr>
-              <a:t>Success means plastic lifted from a real creek and a trustworthy weekly record of what it was.</a:t>
+              <a:t>Success means plastic lifted from a real creek, a trustworthy weekly record of what it was and a flood alarm that works.</a:t>
             </a:r>
             <a:endParaRPr sz="1100">
               <a:solidFill>
@@ -10859,7 +10859,7 @@
                   <a:schemeClr val="dk1"/>
                 </a:solidFill>
               </a:rPr>
-              <a:t> (1) At least 50% capture against a baseline week and 20 kg lifted in 8 weeks. (2) At least 1,000 classified items, weekly counts within 15% of the hand audit and 85% precision and recall on unseen places. (3) At least 2 more sites by March 2027 at about PHP 12,000 each, with weekly labor hours reported.</a:t>
+              <a:t> (1) At least 50% of floating debris removed in the patrol stretch against a baseline week, and 20 kg lifted in 8 weeks. (2) At least 1,000 classified items, weekly counts within 15% of the hand audit, 85% precision and recall on unseen places, and a flood alarm that sounds at all three marks. (3) At least 2 more sites by March 2027 at about PHP 16,000 each, with weekly labor hours reported.</a:t>
             </a:r>
             <a:endParaRPr sz="1100">
               <a:solidFill>
@@ -10895,7 +10895,7 @@
                   <a:schemeClr val="dk1"/>
                 </a:solidFill>
               </a:rPr>
-              <a:t> a student-built, barangay-owned network of units along connected creeks, feeding one open dataset that shows where plastic enters, which products dominate and whether EPR commitments change what the water carries. Planned upgrades are a belt conveyor and a second camera angle.</a:t>
+              <a:t> a student-built, barangay-owned network of units along connected creeks, feeding one open dataset that shows where plastic enters, which products dominate and whether EPR commitments change what the water carries. Planned upgrades are a longer patrol stretch and a second boat.</a:t>
             </a:r>
             <a:endParaRPr sz="1100">
               <a:solidFill>

</xml_diff>

<commit_message>
Update entry PPT with reviewer-comment changes: Dario River, scoreboard, barriers, light and fog control, mixed-item handling, augmentation, deep sleep, end of life
Build script now reads the official template directly.

Co-Authored-By: Claude Sonnet 5.5 <noreply@anthropic.com>
Claude-Session: https://claude.ai/code/session_01BeuSv9ktphNSqgYLtwXpw3
</commit_message>
<xml_diff>
--- a/sft_entry/SAGIP_SFT2026_Entry_PPT.pptx
+++ b/sft_entry/SAGIP_SFT2026_Entry_PPT.pptx
@@ -9991,7 +9991,7 @@
                   <a:schemeClr val="dk1"/>
                 </a:solidFill>
               </a:rPr>
-              <a:t>the [N] households of [barangay and purok] along [estero site] in Quezon City, who also gain a flood alarm, and the barangay sanitation officers. </a:t>
+              <a:t>the [N] households of [barangay and purok] along Dario River in Quezon City, who gain a flood alarm and a monthly Plastic Trend Scoreboard, and the sanitation officers. </a:t>
             </a:r>
             <a:r>
               <a:rPr b="1" lang="en" sz="1100">
@@ -10376,7 +10376,7 @@
                 <a:spcPts val="1200"/>
               </a:spcBef>
               <a:spcAft>
-                <a:spcPts val="1200"/>
+                <a:spcPts val="0"/>
               </a:spcAft>
               <a:buSzPts val="1800"/>
               <a:buNone/>
@@ -10395,7 +10395,7 @@
                   <a:schemeClr val="dk1"/>
                 </a:solidFill>
               </a:rPr>
-              <a:t>A solar-charged robot boat patrols the creek between two barriers. A bow camera spots floating debris, the boat steers to it, and a scoop lifts it onto a conveyor where a second camera runs a small 2D CNN (Gholami et al., 2021, David et al., 2021). A servo gate drops plastic into Bin A and plants or unsure items into Bin B. A weekly offline report gives counts, estimated kilograms and recovery value, and a float-switch flood alarm at the bank keeps the boat docked in rising water.</a:t>
+              <a:t>A solar robot boat patrols between two barriers, the upstream one angling hyacinth mats to the bank. A bow camera runs an object detector, the boat steers to the plastic it boxes, and a scoop lifts it onto a cleated conveyor, one item per pocket. A second camera runs a 2D CNN (Gholami et al., 2021, David et al., 2021), and a servo gate sends plastic to Bin A and plants, mixed or unsure items to Bin B. Weekly reports, a monthly Plastic Trend Scoreboard and a flood alarm serve the barangay.</a:t>
             </a:r>
             <a:endParaRPr b="1" sz="1100">
               <a:solidFill>
@@ -10409,10 +10409,10 @@
                 <a:spcPct val="115000"/>
               </a:lnSpc>
               <a:spcBef>
-                <a:spcPts val="1200"/>
-              </a:spcBef>
-              <a:spcAft>
-                <a:spcPts val="1200"/>
+                <a:spcPts val="600"/>
+              </a:spcBef>
+              <a:spcAft>
+                <a:spcPts val="0"/>
               </a:spcAft>
               <a:buSzPts val="1800"/>
               <a:buNone/>
@@ -10423,7 +10423,7 @@
                   <a:schemeClr val="dk1"/>
                 </a:solidFill>
               </a:rPr>
-              <a:t>STEM. </a:t>
+              <a:t>Reliability. </a:t>
             </a:r>
             <a:r>
               <a:rPr lang="en" sz="1100">
@@ -10431,7 +10431,7 @@
                   <a:schemeClr val="dk1"/>
                 </a:solidFill>
               </a:rPr>
-              <a:t>Physics sets the hull's buoyancy, thrust and the solar budget. Mathematics defines precision, recall and count error. Computer science supplies the detector and the quantized CNN. Engineering joins them in a weatherproof boat.</a:t>
+              <a:t>A skirted hood and fixed LED give every photo the same light, and a hydrophobic film, angled window and desiccant pack keep housings clear of fog. A blob count flags mixed items. Photos are augmented with color shifts, blur, rotation and synthetic mud and droplets.</a:t>
             </a:r>
             <a:endParaRPr b="1" sz="1100">
               <a:solidFill>
@@ -10445,7 +10445,79 @@
                 <a:spcPct val="115000"/>
               </a:lnSpc>
               <a:spcBef>
-                <a:spcPts val="1200"/>
+                <a:spcPts val="600"/>
+              </a:spcBef>
+              <a:spcAft>
+                <a:spcPts val="0"/>
+              </a:spcAft>
+              <a:buSzPts val="1800"/>
+              <a:buNone/>
+            </a:pPr>
+            <a:r>
+              <a:rPr b="1" lang="en" sz="1100">
+                <a:solidFill>
+                  <a:schemeClr val="dk1"/>
+                </a:solidFill>
+              </a:rPr>
+              <a:t>Power and end of life. </a:t>
+            </a:r>
+            <a:r>
+              <a:rPr lang="en" sz="1100">
+                <a:solidFill>
+                  <a:schemeClr val="dk1"/>
+                </a:solidFill>
+              </a:rPr>
+              <a:t>Boards deep-sleep between patrols and the belt camera wakes only for an item. Floats, bins and hardware are PVC, plastic and stainless steel for local salvage, and the flood node's protected 18650 cell sits in an IP67 box.</a:t>
+            </a:r>
+            <a:endParaRPr b="1" sz="1100">
+              <a:solidFill>
+                <a:schemeClr val="dk1"/>
+              </a:solidFill>
+            </a:endParaRPr>
+          </a:p>
+          <a:p>
+            <a:pPr indent="0" lvl="0" marL="0" rtl="0" algn="l">
+              <a:lnSpc>
+                <a:spcPct val="115000"/>
+              </a:lnSpc>
+              <a:spcBef>
+                <a:spcPts val="600"/>
+              </a:spcBef>
+              <a:spcAft>
+                <a:spcPts val="0"/>
+              </a:spcAft>
+              <a:buSzPts val="1800"/>
+              <a:buNone/>
+            </a:pPr>
+            <a:r>
+              <a:rPr b="1" lang="en" sz="1100">
+                <a:solidFill>
+                  <a:schemeClr val="dk1"/>
+                </a:solidFill>
+              </a:rPr>
+              <a:t>STEM. </a:t>
+            </a:r>
+            <a:r>
+              <a:rPr lang="en" sz="1100">
+                <a:solidFill>
+                  <a:schemeClr val="dk1"/>
+                </a:solidFill>
+              </a:rPr>
+              <a:t>Physics sets buoyancy, thrust and the solar budget, mathematics defines precision, recall and count error, and computer science supplies the detector and CNN.</a:t>
+            </a:r>
+            <a:endParaRPr b="1" sz="1100">
+              <a:solidFill>
+                <a:schemeClr val="dk1"/>
+              </a:solidFill>
+            </a:endParaRPr>
+          </a:p>
+          <a:p>
+            <a:pPr indent="0" lvl="0" marL="0" rtl="0" algn="l">
+              <a:lnSpc>
+                <a:spcPct val="115000"/>
+              </a:lnSpc>
+              <a:spcBef>
+                <a:spcPts val="600"/>
               </a:spcBef>
               <a:spcAft>
                 <a:spcPts val="1200"/>
@@ -10467,7 +10539,7 @@
                   <a:schemeClr val="dk1"/>
                 </a:solidFill>
               </a:rPr>
-              <a:t>Proof of what plastic reaches a creek can be continuous, cheap and community-owned, and one robot collects and counts it.</a:t>
+              <a:t>Proof of what plastic reaches a creek can be continuous, cheap and community-owned.</a:t>
             </a:r>
             <a:endParaRPr b="1" sz="1100">
               <a:solidFill>
@@ -10699,7 +10771,7 @@
                   <a:schemeClr val="dk1"/>
                 </a:solidFill>
               </a:rPr>
-              <a:t> Manual labor: bin emptying and snag clearing, logged in hours. Stability: foam-filled floats, tilt cut-off, pond tests. Navigation: barriers, side sensors, compass and phone remote. Hyacinth: plant class and shrouded propellers. Fast water: stays docked. Permission: barangay and city approval.</a:t>
+              <a:t> Manual labor: bin emptying and snag clearing, logged in hours. Stability: foam-filled floats, tilt cut-off, pond tests. Navigation: barriers, side sensors, compass and phone remote. Hyacinth: upstream barrier, plant class and shrouded propellers. Fog, glare and mixed items: hood, hydrophobic film, angled window and a blob count that sends mixed items to Bin B. Fast water: stays docked. Permission: barangay and city approval.</a:t>
             </a:r>
             <a:endParaRPr sz="1100">
               <a:solidFill>
@@ -10859,7 +10931,7 @@
                   <a:schemeClr val="dk1"/>
                 </a:solidFill>
               </a:rPr>
-              <a:t> (1) At least 50% of floating debris removed in the patrol stretch against a baseline week, and 20 kg lifted in 8 weeks. (2) At least 1,000 classified items, weekly counts within 15% of the hand audit, 85% precision and recall on unseen places, and a flood alarm that sounds at all three marks. (3) At least 2 more sites by March 2027 at about PHP 16,000 each, with weekly labor hours reported.</a:t>
+              <a:t> (1) At least 50% of floating debris removed in the patrol stretch against a baseline week, and 20 kg lifted in 8 weeks. (2) At least 1,000 classified items, weekly counts within 15% of the hand audit, 85% precision and recall on unseen places, and a flood alarm that sounds at all three marks. (3) At least 2 more sites by March 2027 at about PHP 16,000 each, with weekly labor hours reported and a monthly Plastic Trend Scoreboard at the Barangay Hall.</a:t>
             </a:r>
             <a:endParaRPr sz="1100">
               <a:solidFill>

</xml_diff>

<commit_message>
Strengthen barrier mechanics and deep-sleep protocol across proposal, PPT and prototype doc
Co-Authored-By: Claude Sonnet 5.5 <noreply@anthropic.com>
Claude-Session: https://claude.ai/code/session_01BeuSv9ktphNSqgYLtwXpw3
</commit_message>
<xml_diff>
--- a/sft_entry/SAGIP_SFT2026_Entry_PPT.pptx
+++ b/sft_entry/SAGIP_SFT2026_Entry_PPT.pptx
@@ -10395,7 +10395,7 @@
                   <a:schemeClr val="dk1"/>
                 </a:solidFill>
               </a:rPr>
-              <a:t>A solar robot boat patrols between two barriers, the upstream one angling hyacinth mats to the bank. A bow camera runs an object detector, the boat steers to the plastic it boxes, and a scoop lifts it onto a cleated conveyor, one item per pocket. A second camera runs a 2D CNN (Gholami et al., 2021, David et al., 2021), and a servo gate sends plastic to Bin A and plants, mixed or unsure items to Bin B. Weekly reports, a monthly Plastic Trend Scoreboard and a flood alarm serve the barangay.</a:t>
+              <a:t>A solar robot boat patrols between two barriers, the upstream one a 30-degree float rope that angles mats to the bank. A bow camera runs an object detector, the boat steers to the plastic it boxes, and a scoop lifts it onto a cleated conveyor, one item per pocket. A second camera runs a 2D CNN (Gholami et al., 2021, David et al., 2021), and a servo gate sends plastic to Bin A and plants, mixed or unsure items to Bin B. Weekly reports, a monthly Plastic Trend Scoreboard and a flood alarm serve the barangay.</a:t>
             </a:r>
             <a:endParaRPr b="1" sz="1100">
               <a:solidFill>
@@ -10467,7 +10467,7 @@
                   <a:schemeClr val="dk1"/>
                 </a:solidFill>
               </a:rPr>
-              <a:t>Boards deep-sleep between patrols and the belt camera wakes only for an item. Floats, bins and hardware are PVC, plastic and stainless steel for local salvage, and the flood node's protected 18650 cell sits in an IP67 box.</a:t>
+              <a:t>Boards deep-sleep between patrols (6 mA asleep, 180 mA awake) and the belt camera wakes only for an item. Parts are PVC, plastic and steel that junk shops take, and the flood node's protected 18650 cell sits in an IP67 box.</a:t>
             </a:r>
             <a:endParaRPr b="1" sz="1100">
               <a:solidFill>

</xml_diff>

<commit_message>
Rewrite SAGIP entry text as narrative paragraphs, update budget and navigation, new title, rebuild Word, PPT and prototype doc
Co-Authored-By: Claude Sonnet 5.5 <noreply@anthropic.com>
Claude-Session: https://claude.ai/code/session_01BeuSv8gNSQPUFpVS1TZhEc
</commit_message>
<xml_diff>
--- a/sft_entry/SAGIP_SFT2026_Entry_PPT.pptx
+++ b/sft_entry/SAGIP_SFT2026_Entry_PPT.pptx
@@ -9514,7 +9514,7 @@
             </a:pPr>
             <a:r>
               <a:rPr b="1" lang="en" sz="2600"/>
-              <a:t>SAGIP: Autonomous Solar Skimmer Boat with On-Chip AI</a:t>
+              <a:t>SAGIP: A Self-Navigating Boat That Collects and Counts Creek Plastic</a:t>
             </a:r>
             <a:endParaRPr b="1" sz="2600"/>
           </a:p>
@@ -9693,7 +9693,7 @@
                   <a:schemeClr val="dk1"/>
                 </a:solidFill>
               </a:rPr>
-              <a:t>SAGIP is a low-cost, solar-powered robot boat that patrols a creek, goes to floating debris, lifts it onto a conveyor and names each item using a small on-chip neural network running on an ESP32 chip. Barangay officials get a weekly report of the plastic collected by type and weight through an offline phone page, plus a float-switch flood alarm at the bank. Built for about PHP 16,000 from local parts, it adds anonymized records to an open dataset that other barangays can copy.</a:t>
+              <a:t>SAGIP is a low-cost, solar-powered robot boat that patrols a creek, goes to floating debris, lifts it onto a conveyor and names each item using a small on-chip neural network running on an ESP32 chip. Barangay officials get a weekly report of the plastic collected by type and weight through an offline phone page, plus a float-switch flood alarm at the bank. Built for about PHP 15,800 from local parts, it adds anonymized records to an open dataset that other barangays can copy.</a:t>
             </a:r>
             <a:endParaRPr i="1" sz="1100">
               <a:solidFill>
@@ -9920,7 +9920,7 @@
                   <a:schemeClr val="dk1"/>
                 </a:solidFill>
               </a:rPr>
-              <a:t>: (1) In an 8-week pilot from January 2027, remove at least 50% of the floating debris entering a 30 m patrol stretch, lift at least 20 kg and log at least 1,000 classified items. (2) By December 5, reach 85% precision and recall on unseen photos, with weekly counts within 15% of a hand audit. (3) By March 2027, publish an open dataset and build guide and help 2 more barangays or schools build a PHP 16,000 unit.</a:t>
+              <a:t>: (1) In an 8-week pilot from January 2027, remove at least 50% of the floating debris entering a 30 m patrol stretch, lift at least 20 kg and log at least 1,000 classified items. (2) By December 5, reach 85% precision and recall on unseen photos, with weekly counts within 15% of a hand audit. (3) By March 2027, publish an open dataset and build guide and help 2 more barangays or schools build a PHP 15,800 unit.</a:t>
             </a:r>
             <a:endParaRPr sz="1100">
               <a:solidFill>
@@ -10223,7 +10223,7 @@
                   <a:schemeClr val="dk1"/>
                 </a:solidFill>
               </a:rPr>
-              <a:t>No system we found patrols a creek, collects plastic, counts it item by item and shares open data at barangay cost. Can a PHP 16,000 robot boat match a hand audit within 15%, and does continuous counting show rain-driven pulses of plastic (van Emmerik et al., 2022) that weekly audits miss?</a:t>
+              <a:t>No system we found patrols a creek, collects plastic, counts it item by item and shares open data at barangay cost. Can a PHP 15,800 robot boat match a hand audit within 15%, and does continuous counting show rain-driven pulses of plastic (van Emmerik et al., 2022) that weekly audits miss?</a:t>
             </a:r>
             <a:endParaRPr b="1" sz="1100">
               <a:solidFill>
@@ -10395,7 +10395,7 @@
                   <a:schemeClr val="dk1"/>
                 </a:solidFill>
               </a:rPr>
-              <a:t>A solar robot boat patrols between two barriers, the upstream one a 30-degree float rope that angles mats to the bank. A bow camera runs an object detector, the boat steers to the plastic it boxes, and a scoop lifts it onto a cleated conveyor, one item per pocket. A second camera runs a 2D CNN (Gholami et al., 2021, David et al., 2021), and a servo gate sends plastic to Bin A and plants, mixed or unsure items to Bin B. Weekly reports, a monthly Plastic Trend Scoreboard and a flood alarm serve the barangay.</a:t>
+              <a:t>A solar robot boat navigates on its own between two barriers, the upstream one a 30-degree float rope that angles mats to the bank. A bow camera runs an object detector, the boat steers to the plastic it boxes, and a scoop lifts it onto a cleated conveyor, one item per pocket. A second camera runs a 2D CNN (Gholami et al., 2021, David et al., 2021), and a servo gate sends plastic to Bin A and plants, mixed or unsure items to Bin B. Weekly reports, a monthly Plastic Trend Scoreboard and a flood alarm serve the barangay.</a:t>
             </a:r>
             <a:endParaRPr b="1" sz="1100">
               <a:solidFill>
@@ -10663,7 +10663,7 @@
                   <a:schemeClr val="dk1"/>
                 </a:solidFill>
               </a:rPr>
-              <a:t>A pilot unit costs about PHP 16,000, built in three stages that are each bought only after the previous test passes.</a:t>
+              <a:t>A pilot unit costs about PHP 15,800, built in three stages that are each bought only after the previous test passes.</a:t>
             </a:r>
             <a:endParaRPr sz="1100">
               <a:solidFill>
@@ -10699,7 +10699,7 @@
                   <a:schemeClr val="dk1"/>
                 </a:solidFill>
               </a:rPr>
-              <a:t> floats, frame and deck 2,300, thrusters 1,800, conveyor 2,000, ESP32-S3 camera set 1,850, bow detector 600, sensors 900, gate and bins 300, battery and wiring 2,400, 30 W panel 1,100, hardware 500, flood node 1,000, dock and barriers 600, contingency 650. Stages: bench 7,650, boat 6,100, dock and flood node 1,600. Timeline: screening Nov 9 to 13, mentorship Nov 16 to Dec 5, pitch Dec 7, creek pilot Jan to Feb.</a:t>
+              <a:t> floats, frame and deck 3,228, thrusters 2,410, conveyor 1,500, ESP32-S3 camera set 700, bow detector 600, sensors 680, gate and bins 300, battery and wiring 2,400, 30 W panel 1,100, hardware 500, flood node 1,000, dock and barriers 600, contingency 782. Stages: bench 6,000, boat 7,400, dock and flood node 1,600. Timeline: screening Nov 9 to 13, mentorship Nov 16 to Dec 5, pitch Dec 7, creek pilot Jan to Feb.</a:t>
             </a:r>
             <a:endParaRPr sz="1100">
               <a:solidFill>
@@ -10771,7 +10771,7 @@
                   <a:schemeClr val="dk1"/>
                 </a:solidFill>
               </a:rPr>
-              <a:t> Manual labor: bin emptying and snag clearing, logged in hours. Stability: foam-filled floats, tilt cut-off, pond tests. Navigation: barriers, side sensors, compass and phone remote. Hyacinth: upstream barrier, plant class and shrouded propellers. Fog, glare and mixed items: hood, hydrophobic film, angled window and a blob count that sends mixed items to Bin B. Fast water: stays docked. Permission: barangay and city approval.</a:t>
+              <a:t> Manual labor: bin emptying and snag clearing, logged in hours. Stability: foam-filled floats, tilt cut-off, pond tests. Navigation: a preset route, barriers, side sensors and a stop switch. Hyacinth: upstream barrier, plant class and shrouded propellers. Fog, glare and mixed items: hood, hydrophobic film, angled window and a blob count that sends mixed items to Bin B. Fast water: stays docked. Permission: barangay and city approval.</a:t>
             </a:r>
             <a:endParaRPr sz="1100">
               <a:solidFill>
@@ -10931,7 +10931,7 @@
                   <a:schemeClr val="dk1"/>
                 </a:solidFill>
               </a:rPr>
-              <a:t> (1) At least 50% of floating debris removed in the patrol stretch against a baseline week, and 20 kg lifted in 8 weeks. (2) At least 1,000 classified items, weekly counts within 15% of the hand audit, 85% precision and recall on unseen places, and a flood alarm that sounds at all three marks. (3) At least 2 more sites by March 2027 at about PHP 16,000 each, with weekly labor hours reported and a monthly Plastic Trend Scoreboard at the Barangay Hall.</a:t>
+              <a:t> (1) At least 50% of floating debris removed in the patrol stretch against a baseline week, and 20 kg lifted in 8 weeks. (2) At least 1,000 classified items, weekly counts within 15% of the hand audit, 85% precision and recall on unseen places, and a flood alarm that sounds at all three marks. (3) At least 2 more sites by March 2027 at about PHP 15,800 each, with weekly labor hours reported and a monthly Plastic Trend Scoreboard at the Barangay Hall.</a:t>
             </a:r>
             <a:endParaRPr sz="1100">
               <a:solidFill>

</xml_diff>

<commit_message>
Use neutral wording for unconfirmed site details, about 30 kg, generic Select paragraph
Co-Authored-By: Claude Sonnet 5.5 <noreply@anthropic.com>
Claude-Session: https://claude.ai/code/session_01BeuSv8gNSQPUFpVS1TZhEc
</commit_message>
<xml_diff>
--- a/sft_entry/SAGIP_SFT2026_Entry_PPT.pptx
+++ b/sft_entry/SAGIP_SFT2026_Entry_PPT.pptx
@@ -9991,7 +9991,7 @@
                   <a:schemeClr val="dk1"/>
                 </a:solidFill>
               </a:rPr>
-              <a:t>the households of [Barangay Santo Cristo, Bago Bantay] ([6,531 on record, confirm creek-side count]) along Dario River in Quezon City, who gain a flood alarm and a monthly Plastic Trend Scoreboard, and the sanitation officers. </a:t>
+              <a:t>the households along Dario River in Quezon City, who gain a flood alarm and a monthly Plastic Trend Scoreboard, and the sanitation officers. </a:t>
             </a:r>
             <a:r>
               <a:rPr b="1" lang="en" sz="1100">
@@ -10143,7 +10143,7 @@
                   <a:schemeClr val="dk1"/>
                 </a:solidFill>
               </a:rPr>
-              <a:t>We scored five community problems on significance, feasibility, STEM depth, replicability and originality. Creek plastic won. [Edit to match your process.]</a:t>
+              <a:t>We considered community problems against five criteria: significance, feasibility, STEM depth, replicability and originality. Creek plastic fit best because we can reach a creek and measure it weekly.</a:t>
             </a:r>
             <a:endParaRPr b="1" sz="1100">
               <a:solidFill>

</xml_diff>